<commit_message>
docs: documentación extensa (Word 17 secciones + apéndices, PPT 15 láminas)
Amplía la documentación a nivel plataforma: introducción/propuesta de valor,
glosario, arquitectura y flujo de petición, modelo de privacidad y ruteo
(NaN-primero), RAG, cascada/eficiencia, módulos funcionales (12), integraciones,
toolkit de acciones (tabla), modelos/proveedores + modelos de NaN, roles y
multi-tenant, seguridad/cumplimiento, entornos/CI-CD, configuración (variables
de entorno), operación/soporte, planes y roadmap. Apéndices: catálogo de
endpoints (131) y variables de entorno.

Generador reproducible en scripts/gen_docs.py (OUT_DIR=... python scripts/gen_docs.py).

Co-Authored-By: Claude Opus 4.8 <noreply@anthropic.com>
Claude-Session: https://claude.ai/code/session_01HTAvTHuepv1vkFtVGxRvVu
</commit_message>
<xml_diff>
--- a/docs/generados/MaestroAI-Presentacion.pptx
+++ b/docs/generados/MaestroAI-Presentacion.pptx
@@ -16,6 +16,10 @@
     <p:sldId id="264" r:id="rId15"/>
     <p:sldId id="265" r:id="rId16"/>
     <p:sldId id="266" r:id="rId17"/>
+    <p:sldId id="267" r:id="rId18"/>
+    <p:sldId id="268" r:id="rId19"/>
+    <p:sldId id="269" r:id="rId20"/>
+    <p:sldId id="270" r:id="rId21"/>
   </p:sldIdLst>
   <p:sldSz cx="12191695" cy="6858000" type="screen4x3"/>
   <p:notesSz cx="6858000" cy="9144000"/>
@@ -3123,13 +3127,13 @@
           <a:noFill/>
         </p:spPr>
         <p:txBody>
-          <a:bodyPr wrap="square">
+          <a:bodyPr wrap="none">
             <a:spAutoFit/>
           </a:bodyPr>
           <a:lstStyle/>
           <a:p>
             <a:r>
-              <a:rPr sz="4000" b="1">
+              <a:rPr sz="3800" b="1">
                 <a:solidFill>
                   <a:srgbClr val="FFFFFF"/>
                 </a:solidFill>
@@ -3162,12 +3166,12 @@
           <a:lstStyle/>
           <a:p>
             <a:r>
-              <a:rPr sz="1800">
+              <a:rPr sz="1600">
                 <a:solidFill>
                   <a:srgbClr val="FFFFFF"/>
                 </a:solidFill>
               </a:rPr>
-              <a:t>AI privada y gobernada para empresas — Private AI Gateway + agentes verticales</a:t>
+              <a:t>Documentación técnica y funcional · 2026</a:t>
             </a:r>
           </a:p>
         </p:txBody>
@@ -3198,7 +3202,7 @@
         </p:nvSpPr>
         <p:spPr>
           <a:xfrm>
-            <a:off x="640080" y="457200"/>
+            <a:off x="640080" y="411480"/>
             <a:ext cx="10972800" cy="1097280"/>
           </a:xfrm>
           <a:prstGeom prst="rect">
@@ -3207,18 +3211,18 @@
           <a:noFill/>
         </p:spPr>
         <p:txBody>
-          <a:bodyPr wrap="square">
+          <a:bodyPr wrap="none">
             <a:spAutoFit/>
           </a:bodyPr>
           <a:lstStyle/>
           <a:p>
             <a:r>
-              <a:rPr sz="3000" b="1">
+              <a:rPr sz="2800" b="1">
                 <a:solidFill>
                   <a:srgbClr val="6D28D9"/>
                 </a:solidFill>
               </a:rPr>
-              <a:t>Pendientes del cliente</a:t>
+              <a:t>Modelos de NaN</a:t>
             </a:r>
           </a:p>
         </p:txBody>
@@ -3231,8 +3235,8 @@
         </p:nvSpPr>
         <p:spPr>
           <a:xfrm>
-            <a:off x="640080" y="1463040"/>
-            <a:ext cx="10972800" cy="914400"/>
+            <a:off x="731520" y="1554480"/>
+            <a:ext cx="10698480" cy="4846320"/>
           </a:xfrm>
           <a:prstGeom prst="rect">
             <a:avLst/>
@@ -3240,39 +3244,6 @@
           <a:noFill/>
         </p:spPr>
         <p:txBody>
-          <a:bodyPr wrap="none">
-            <a:spAutoFit/>
-          </a:bodyPr>
-          <a:lstStyle/>
-          <a:p>
-            <a:r>
-              <a:rPr sz="1800">
-                <a:solidFill>
-                  <a:srgbClr val="64748B"/>
-                </a:solidFill>
-              </a:rPr>
-              <a:t>Lo único que requiere admin/credenciales del cliente.</a:t>
-            </a:r>
-          </a:p>
-        </p:txBody>
-      </p:sp>
-      <p:sp>
-        <p:nvSpPr>
-          <p:cNvPr id="4" name="TextBox 3"/>
-          <p:cNvSpPr txBox="1"/>
-          <p:nvPr/>
-        </p:nvSpPr>
-        <p:spPr>
-          <a:xfrm>
-            <a:off x="731520" y="1645920"/>
-            <a:ext cx="10698480" cy="4754880"/>
-          </a:xfrm>
-          <a:prstGeom prst="rect">
-            <a:avLst/>
-          </a:prstGeom>
-          <a:noFill/>
-        </p:spPr>
-        <p:txBody>
           <a:bodyPr wrap="square">
             <a:spAutoFit/>
           </a:bodyPr>
@@ -3280,46 +3251,93 @@
           <a:p>
             <a:pPr>
               <a:spcAft>
-                <a:spcPts val="800"/>
+                <a:spcPts val="600"/>
               </a:spcAft>
             </a:pPr>
             <a:r>
-              <a:rPr sz="1600">
+              <a:rPr b="1" sz="1500">
                 <a:solidFill>
                   <a:srgbClr val="334155"/>
                 </a:solidFill>
               </a:rPr>
-              <a:t>• Proteger ramas (main/qa) en GitHub — requiere admin del repo.</a:t>
+              <a:t>qwen3.6: </a:t>
+            </a:r>
+            <a:r>
+              <a:rPr sz="1300">
+                <a:solidFill>
+                  <a:srgbClr val="64748B"/>
+                </a:solidFill>
+              </a:rPr>
+              <a:t>principal (chat, tools, visión, reasoning).</a:t>
             </a:r>
           </a:p>
           <a:p>
             <a:pPr>
               <a:spcAft>
-                <a:spcPts val="800"/>
+                <a:spcPts val="600"/>
               </a:spcAft>
             </a:pPr>
             <a:r>
-              <a:rPr sz="1600">
+              <a:rPr b="1" sz="1500">
                 <a:solidFill>
                   <a:srgbClr val="334155"/>
                 </a:solidFill>
               </a:rPr>
-              <a:t>• Reconectar Microsoft con scopes nuevos (Excel/SharePoint/OneDrive).</a:t>
+              <a:t>deepseek-v4-flash / mimo-v2.5: </a:t>
+            </a:r>
+            <a:r>
+              <a:rPr sz="1300">
+                <a:solidFill>
+                  <a:srgbClr val="64748B"/>
+                </a:solidFill>
+              </a:rPr>
+              <a:t>1M tokens; mimo omnimodal.</a:t>
             </a:r>
           </a:p>
           <a:p>
             <a:pPr>
               <a:spcAft>
-                <a:spcPts val="800"/>
+                <a:spcPts val="600"/>
               </a:spcAft>
             </a:pPr>
             <a:r>
-              <a:rPr sz="1600">
+              <a:rPr b="1" sz="1500">
                 <a:solidFill>
                   <a:srgbClr val="334155"/>
                 </a:solidFill>
               </a:rPr>
-              <a:t>• Configurar proveedor premium/NaN y «Probar conexión».</a:t>
+              <a:t>qwen3-embedding / rerank: </a:t>
+            </a:r>
+            <a:r>
+              <a:rPr sz="1300">
+                <a:solidFill>
+                  <a:srgbClr val="64748B"/>
+                </a:solidFill>
+              </a:rPr>
+              <a:t>stack RAG.</a:t>
+            </a:r>
+          </a:p>
+          <a:p>
+            <a:pPr>
+              <a:spcAft>
+                <a:spcPts val="600"/>
+              </a:spcAft>
+            </a:pPr>
+            <a:r>
+              <a:rPr b="1" sz="1500">
+                <a:solidFill>
+                  <a:srgbClr val="334155"/>
+                </a:solidFill>
+              </a:rPr>
+              <a:t>kokoro / whisper: </a:t>
+            </a:r>
+            <a:r>
+              <a:rPr sz="1300">
+                <a:solidFill>
+                  <a:srgbClr val="64748B"/>
+                </a:solidFill>
+              </a:rPr>
+              <a:t>TTS / STT.</a:t>
             </a:r>
           </a:p>
         </p:txBody>
@@ -3333,6 +3351,560 @@
 </file>
 
 <file path=ppt/slides/slide11.xml><?xml version="1.0" encoding="utf-8"?>
+<p:sld xmlns:a="http://schemas.openxmlformats.org/drawingml/2006/main" xmlns:p="http://schemas.openxmlformats.org/presentationml/2006/main" xmlns:r="http://schemas.openxmlformats.org/officeDocument/2006/relationships">
+  <p:cSld>
+    <p:spTree>
+      <p:nvGrpSpPr>
+        <p:cNvPr id="1" name=""/>
+        <p:cNvGrpSpPr/>
+        <p:nvPr/>
+      </p:nvGrpSpPr>
+      <p:grpSpPr/>
+      <p:sp>
+        <p:nvSpPr>
+          <p:cNvPr id="2" name="TextBox 1"/>
+          <p:cNvSpPr txBox="1"/>
+          <p:nvPr/>
+        </p:nvSpPr>
+        <p:spPr>
+          <a:xfrm>
+            <a:off x="640080" y="411480"/>
+            <a:ext cx="10972800" cy="1097280"/>
+          </a:xfrm>
+          <a:prstGeom prst="rect">
+            <a:avLst/>
+          </a:prstGeom>
+          <a:noFill/>
+        </p:spPr>
+        <p:txBody>
+          <a:bodyPr wrap="none">
+            <a:spAutoFit/>
+          </a:bodyPr>
+          <a:lstStyle/>
+          <a:p>
+            <a:r>
+              <a:rPr sz="2800" b="1">
+                <a:solidFill>
+                  <a:srgbClr val="6D28D9"/>
+                </a:solidFill>
+              </a:rPr>
+              <a:t>Seguridad y cumplimiento</a:t>
+            </a:r>
+          </a:p>
+        </p:txBody>
+      </p:sp>
+      <p:sp>
+        <p:nvSpPr>
+          <p:cNvPr id="3" name="TextBox 2"/>
+          <p:cNvSpPr txBox="1"/>
+          <p:nvPr/>
+        </p:nvSpPr>
+        <p:spPr>
+          <a:xfrm>
+            <a:off x="731520" y="1554480"/>
+            <a:ext cx="10698480" cy="4846320"/>
+          </a:xfrm>
+          <a:prstGeom prst="rect">
+            <a:avLst/>
+          </a:prstGeom>
+          <a:noFill/>
+        </p:spPr>
+        <p:txBody>
+          <a:bodyPr wrap="square">
+            <a:spAutoFit/>
+          </a:bodyPr>
+          <a:lstStyle/>
+          <a:p>
+            <a:pPr>
+              <a:spcAft>
+                <a:spcPts val="600"/>
+              </a:spcAft>
+            </a:pPr>
+            <a:r>
+              <a:rPr sz="1500">
+                <a:solidFill>
+                  <a:srgbClr val="334155"/>
+                </a:solidFill>
+              </a:rPr>
+              <a:t>• Cifrado en reposo AES-256-GCM por tenant.</a:t>
+            </a:r>
+          </a:p>
+          <a:p>
+            <a:pPr>
+              <a:spcAft>
+                <a:spcPts val="600"/>
+              </a:spcAft>
+            </a:pPr>
+            <a:r>
+              <a:rPr sz="1500">
+                <a:solidFill>
+                  <a:srgbClr val="334155"/>
+                </a:solidFill>
+              </a:rPr>
+              <a:t>• Redacción de PII y minimización de contexto.</a:t>
+            </a:r>
+          </a:p>
+          <a:p>
+            <a:pPr>
+              <a:spcAft>
+                <a:spcPts val="600"/>
+              </a:spcAft>
+            </a:pPr>
+            <a:r>
+              <a:rPr sz="1500">
+                <a:solidFill>
+                  <a:srgbClr val="334155"/>
+                </a:solidFill>
+              </a:rPr>
+              <a:t>• Auditoría total + export a SIEM.</a:t>
+            </a:r>
+          </a:p>
+          <a:p>
+            <a:pPr>
+              <a:spcAft>
+                <a:spcPts val="600"/>
+              </a:spcAft>
+            </a:pPr>
+            <a:r>
+              <a:rPr sz="1500">
+                <a:solidFill>
+                  <a:srgbClr val="334155"/>
+                </a:solidFill>
+              </a:rPr>
+              <a:t>• LFPDPPP · OWASP LLM 2025 · NIST AI RMF.</a:t>
+            </a:r>
+          </a:p>
+        </p:txBody>
+      </p:sp>
+    </p:spTree>
+  </p:cSld>
+  <p:clrMapOvr>
+    <a:masterClrMapping/>
+  </p:clrMapOvr>
+</p:sld>
+</file>
+
+<file path=ppt/slides/slide12.xml><?xml version="1.0" encoding="utf-8"?>
+<p:sld xmlns:a="http://schemas.openxmlformats.org/drawingml/2006/main" xmlns:p="http://schemas.openxmlformats.org/presentationml/2006/main" xmlns:r="http://schemas.openxmlformats.org/officeDocument/2006/relationships">
+  <p:cSld>
+    <p:spTree>
+      <p:nvGrpSpPr>
+        <p:cNvPr id="1" name=""/>
+        <p:cNvGrpSpPr/>
+        <p:nvPr/>
+      </p:nvGrpSpPr>
+      <p:grpSpPr/>
+      <p:sp>
+        <p:nvSpPr>
+          <p:cNvPr id="2" name="TextBox 1"/>
+          <p:cNvSpPr txBox="1"/>
+          <p:nvPr/>
+        </p:nvSpPr>
+        <p:spPr>
+          <a:xfrm>
+            <a:off x="640080" y="411480"/>
+            <a:ext cx="10972800" cy="1097280"/>
+          </a:xfrm>
+          <a:prstGeom prst="rect">
+            <a:avLst/>
+          </a:prstGeom>
+          <a:noFill/>
+        </p:spPr>
+        <p:txBody>
+          <a:bodyPr wrap="none">
+            <a:spAutoFit/>
+          </a:bodyPr>
+          <a:lstStyle/>
+          <a:p>
+            <a:r>
+              <a:rPr sz="2800" b="1">
+                <a:solidFill>
+                  <a:srgbClr val="6D28D9"/>
+                </a:solidFill>
+              </a:rPr>
+              <a:t>Roles y gobierno</a:t>
+            </a:r>
+          </a:p>
+        </p:txBody>
+      </p:sp>
+      <p:sp>
+        <p:nvSpPr>
+          <p:cNvPr id="3" name="TextBox 2"/>
+          <p:cNvSpPr txBox="1"/>
+          <p:nvPr/>
+        </p:nvSpPr>
+        <p:spPr>
+          <a:xfrm>
+            <a:off x="731520" y="1554480"/>
+            <a:ext cx="10698480" cy="4846320"/>
+          </a:xfrm>
+          <a:prstGeom prst="rect">
+            <a:avLst/>
+          </a:prstGeom>
+          <a:noFill/>
+        </p:spPr>
+        <p:txBody>
+          <a:bodyPr wrap="square">
+            <a:spAutoFit/>
+          </a:bodyPr>
+          <a:lstStyle/>
+          <a:p>
+            <a:pPr>
+              <a:spcAft>
+                <a:spcPts val="600"/>
+              </a:spcAft>
+            </a:pPr>
+            <a:r>
+              <a:rPr b="1" sz="1500">
+                <a:solidFill>
+                  <a:srgbClr val="334155"/>
+                </a:solidFill>
+              </a:rPr>
+              <a:t>super_admin / admin: </a:t>
+            </a:r>
+            <a:r>
+              <a:rPr sz="1300">
+                <a:solidFill>
+                  <a:srgbClr val="64748B"/>
+                </a:solidFill>
+              </a:rPr>
+              <a:t>multi-tenant / configuración del tenant.</a:t>
+            </a:r>
+          </a:p>
+          <a:p>
+            <a:pPr>
+              <a:spcAft>
+                <a:spcPts val="600"/>
+              </a:spcAft>
+            </a:pPr>
+            <a:r>
+              <a:rPr b="1" sz="1500">
+                <a:solidFill>
+                  <a:srgbClr val="334155"/>
+                </a:solidFill>
+              </a:rPr>
+              <a:t>user / security / devops: </a:t>
+            </a:r>
+            <a:r>
+              <a:rPr sz="1300">
+                <a:solidFill>
+                  <a:srgbClr val="64748B"/>
+                </a:solidFill>
+              </a:rPr>
+              <a:t>uso / auditoría / integraciones.</a:t>
+            </a:r>
+          </a:p>
+          <a:p>
+            <a:pPr>
+              <a:spcAft>
+                <a:spcPts val="600"/>
+              </a:spcAft>
+            </a:pPr>
+            <a:r>
+              <a:rPr b="1" sz="1500">
+                <a:solidFill>
+                  <a:srgbClr val="334155"/>
+                </a:solidFill>
+              </a:rPr>
+              <a:t>Permisos por área y licencia: </a:t>
+            </a:r>
+            <a:r>
+              <a:rPr sz="1300">
+                <a:solidFill>
+                  <a:srgbClr val="64748B"/>
+                </a:solidFill>
+              </a:rPr>
+              <a:t>cada quien ve lo suyo.</a:t>
+            </a:r>
+          </a:p>
+        </p:txBody>
+      </p:sp>
+    </p:spTree>
+  </p:cSld>
+  <p:clrMapOvr>
+    <a:masterClrMapping/>
+  </p:clrMapOvr>
+</p:sld>
+</file>
+
+<file path=ppt/slides/slide13.xml><?xml version="1.0" encoding="utf-8"?>
+<p:sld xmlns:a="http://schemas.openxmlformats.org/drawingml/2006/main" xmlns:p="http://schemas.openxmlformats.org/presentationml/2006/main" xmlns:r="http://schemas.openxmlformats.org/officeDocument/2006/relationships">
+  <p:cSld>
+    <p:spTree>
+      <p:nvGrpSpPr>
+        <p:cNvPr id="1" name=""/>
+        <p:cNvGrpSpPr/>
+        <p:nvPr/>
+      </p:nvGrpSpPr>
+      <p:grpSpPr/>
+      <p:sp>
+        <p:nvSpPr>
+          <p:cNvPr id="2" name="TextBox 1"/>
+          <p:cNvSpPr txBox="1"/>
+          <p:nvPr/>
+        </p:nvSpPr>
+        <p:spPr>
+          <a:xfrm>
+            <a:off x="640080" y="411480"/>
+            <a:ext cx="10972800" cy="1097280"/>
+          </a:xfrm>
+          <a:prstGeom prst="rect">
+            <a:avLst/>
+          </a:prstGeom>
+          <a:noFill/>
+        </p:spPr>
+        <p:txBody>
+          <a:bodyPr wrap="none">
+            <a:spAutoFit/>
+          </a:bodyPr>
+          <a:lstStyle/>
+          <a:p>
+            <a:r>
+              <a:rPr sz="2800" b="1">
+                <a:solidFill>
+                  <a:srgbClr val="6D28D9"/>
+                </a:solidFill>
+              </a:rPr>
+              <a:t>Entornos y operación</a:t>
+            </a:r>
+          </a:p>
+        </p:txBody>
+      </p:sp>
+      <p:sp>
+        <p:nvSpPr>
+          <p:cNvPr id="3" name="TextBox 2"/>
+          <p:cNvSpPr txBox="1"/>
+          <p:nvPr/>
+        </p:nvSpPr>
+        <p:spPr>
+          <a:xfrm>
+            <a:off x="731520" y="1554480"/>
+            <a:ext cx="10698480" cy="4846320"/>
+          </a:xfrm>
+          <a:prstGeom prst="rect">
+            <a:avLst/>
+          </a:prstGeom>
+          <a:noFill/>
+        </p:spPr>
+        <p:txBody>
+          <a:bodyPr wrap="square">
+            <a:spAutoFit/>
+          </a:bodyPr>
+          <a:lstStyle/>
+          <a:p>
+            <a:pPr>
+              <a:spcAft>
+                <a:spcPts val="600"/>
+              </a:spcAft>
+            </a:pPr>
+            <a:r>
+              <a:rPr sz="1500">
+                <a:solidFill>
+                  <a:srgbClr val="334155"/>
+                </a:solidFill>
+              </a:rPr>
+              <a:t>• dev → qa → main con CI obligatorio.</a:t>
+            </a:r>
+          </a:p>
+          <a:p>
+            <a:pPr>
+              <a:spcAft>
+                <a:spcPts val="600"/>
+              </a:spcAft>
+            </a:pPr>
+            <a:r>
+              <a:rPr sz="1500">
+                <a:solidFill>
+                  <a:srgbClr val="334155"/>
+                </a:solidFill>
+              </a:rPr>
+              <a:t>• Despliegue: Vercel (portal) + Render (API).</a:t>
+            </a:r>
+          </a:p>
+          <a:p>
+            <a:pPr>
+              <a:spcAft>
+                <a:spcPts val="600"/>
+              </a:spcAft>
+            </a:pPr>
+            <a:r>
+              <a:rPr sz="1500">
+                <a:solidFill>
+                  <a:srgbClr val="334155"/>
+                </a:solidFill>
+              </a:rPr>
+              <a:t>• Ayuda in-app + contextual (popup) por sección.</a:t>
+            </a:r>
+          </a:p>
+          <a:p>
+            <a:pPr>
+              <a:spcAft>
+                <a:spcPts val="600"/>
+              </a:spcAft>
+            </a:pPr>
+            <a:r>
+              <a:rPr sz="1500">
+                <a:solidFill>
+                  <a:srgbClr val="334155"/>
+                </a:solidFill>
+              </a:rPr>
+              <a:t>• Auditoría navegable de cada acción.</a:t>
+            </a:r>
+          </a:p>
+        </p:txBody>
+      </p:sp>
+    </p:spTree>
+  </p:cSld>
+  <p:clrMapOvr>
+    <a:masterClrMapping/>
+  </p:clrMapOvr>
+</p:sld>
+</file>
+
+<file path=ppt/slides/slide14.xml><?xml version="1.0" encoding="utf-8"?>
+<p:sld xmlns:a="http://schemas.openxmlformats.org/drawingml/2006/main" xmlns:p="http://schemas.openxmlformats.org/presentationml/2006/main" xmlns:r="http://schemas.openxmlformats.org/officeDocument/2006/relationships">
+  <p:cSld>
+    <p:spTree>
+      <p:nvGrpSpPr>
+        <p:cNvPr id="1" name=""/>
+        <p:cNvGrpSpPr/>
+        <p:nvPr/>
+      </p:nvGrpSpPr>
+      <p:grpSpPr/>
+      <p:sp>
+        <p:nvSpPr>
+          <p:cNvPr id="2" name="TextBox 1"/>
+          <p:cNvSpPr txBox="1"/>
+          <p:nvPr/>
+        </p:nvSpPr>
+        <p:spPr>
+          <a:xfrm>
+            <a:off x="640080" y="411480"/>
+            <a:ext cx="10972800" cy="1097280"/>
+          </a:xfrm>
+          <a:prstGeom prst="rect">
+            <a:avLst/>
+          </a:prstGeom>
+          <a:noFill/>
+        </p:spPr>
+        <p:txBody>
+          <a:bodyPr wrap="none">
+            <a:spAutoFit/>
+          </a:bodyPr>
+          <a:lstStyle/>
+          <a:p>
+            <a:r>
+              <a:rPr sz="2800" b="1">
+                <a:solidFill>
+                  <a:srgbClr val="6D28D9"/>
+                </a:solidFill>
+              </a:rPr>
+              <a:t>Roadmap</a:t>
+            </a:r>
+          </a:p>
+        </p:txBody>
+      </p:sp>
+      <p:sp>
+        <p:nvSpPr>
+          <p:cNvPr id="3" name="TextBox 2"/>
+          <p:cNvSpPr txBox="1"/>
+          <p:nvPr/>
+        </p:nvSpPr>
+        <p:spPr>
+          <a:xfrm>
+            <a:off x="731520" y="1554480"/>
+            <a:ext cx="10698480" cy="4846320"/>
+          </a:xfrm>
+          <a:prstGeom prst="rect">
+            <a:avLst/>
+          </a:prstGeom>
+          <a:noFill/>
+        </p:spPr>
+        <p:txBody>
+          <a:bodyPr wrap="square">
+            <a:spAutoFit/>
+          </a:bodyPr>
+          <a:lstStyle/>
+          <a:p>
+            <a:pPr>
+              <a:spcAft>
+                <a:spcPts val="600"/>
+              </a:spcAft>
+            </a:pPr>
+            <a:r>
+              <a:rPr b="1" sz="1500">
+                <a:solidFill>
+                  <a:srgbClr val="334155"/>
+                </a:solidFill>
+              </a:rPr>
+              <a:t>Catálogos de configuración empresarial: </a:t>
+            </a:r>
+            <a:r>
+              <a:rPr sz="1300">
+                <a:solidFill>
+                  <a:srgbClr val="64748B"/>
+                </a:solidFill>
+              </a:rPr>
+              <a:t>en definición.</a:t>
+            </a:r>
+          </a:p>
+          <a:p>
+            <a:pPr>
+              <a:spcAft>
+                <a:spcPts val="600"/>
+              </a:spcAft>
+            </a:pPr>
+            <a:r>
+              <a:rPr b="1" sz="1500">
+                <a:solidFill>
+                  <a:srgbClr val="334155"/>
+                </a:solidFill>
+              </a:rPr>
+              <a:t>TTS/STT (NaN): </a:t>
+            </a:r>
+            <a:r>
+              <a:rPr sz="1300">
+                <a:solidFill>
+                  <a:srgbClr val="64748B"/>
+                </a:solidFill>
+              </a:rPr>
+              <a:t>voz y transcripción.</a:t>
+            </a:r>
+          </a:p>
+          <a:p>
+            <a:pPr>
+              <a:spcAft>
+                <a:spcPts val="600"/>
+              </a:spcAft>
+            </a:pPr>
+            <a:r>
+              <a:rPr b="1" sz="1500">
+                <a:solidFill>
+                  <a:srgbClr val="334155"/>
+                </a:solidFill>
+              </a:rPr>
+              <a:t>SFTP: </a:t>
+            </a:r>
+            <a:r>
+              <a:rPr sz="1300">
+                <a:solidFill>
+                  <a:srgbClr val="64748B"/>
+                </a:solidFill>
+              </a:rPr>
+              <a:t>conector legado.</a:t>
+            </a:r>
+          </a:p>
+        </p:txBody>
+      </p:sp>
+    </p:spTree>
+  </p:cSld>
+  <p:clrMapOvr>
+    <a:masterClrMapping/>
+  </p:clrMapOvr>
+</p:sld>
+</file>
+
+<file path=ppt/slides/slide15.xml><?xml version="1.0" encoding="utf-8"?>
 <p:sld xmlns:a="http://schemas.openxmlformats.org/drawingml/2006/main" xmlns:p="http://schemas.openxmlformats.org/presentationml/2006/main" xmlns:r="http://schemas.openxmlformats.org/officeDocument/2006/relationships">
   <p:cSld>
     <p:bg>
@@ -3367,13 +3939,13 @@
           <a:noFill/>
         </p:spPr>
         <p:txBody>
-          <a:bodyPr wrap="square">
+          <a:bodyPr wrap="none">
             <a:spAutoFit/>
           </a:bodyPr>
           <a:lstStyle/>
           <a:p>
             <a:r>
-              <a:rPr sz="4000" b="1">
+              <a:rPr sz="3800" b="1">
                 <a:solidFill>
                   <a:srgbClr val="FFFFFF"/>
                 </a:solidFill>
@@ -3406,7 +3978,7 @@
           <a:lstStyle/>
           <a:p>
             <a:r>
-              <a:rPr sz="1800">
+              <a:rPr sz="1600">
                 <a:solidFill>
                   <a:srgbClr val="FFFFFF"/>
                 </a:solidFill>
@@ -3442,7 +4014,7 @@
         </p:nvSpPr>
         <p:spPr>
           <a:xfrm>
-            <a:off x="640080" y="457200"/>
+            <a:off x="640080" y="411480"/>
             <a:ext cx="10972800" cy="1097280"/>
           </a:xfrm>
           <a:prstGeom prst="rect">
@@ -3451,18 +4023,18 @@
           <a:noFill/>
         </p:spPr>
         <p:txBody>
-          <a:bodyPr wrap="square">
+          <a:bodyPr wrap="none">
             <a:spAutoFit/>
           </a:bodyPr>
           <a:lstStyle/>
           <a:p>
             <a:r>
-              <a:rPr sz="3000" b="1">
+              <a:rPr sz="2800" b="1">
                 <a:solidFill>
                   <a:srgbClr val="6D28D9"/>
                 </a:solidFill>
               </a:rPr>
-              <a:t>¿Qué es?</a:t>
+              <a:t>El problema</a:t>
             </a:r>
           </a:p>
         </p:txBody>
@@ -3475,7 +4047,7 @@
         </p:nvSpPr>
         <p:spPr>
           <a:xfrm>
-            <a:off x="640080" y="1463040"/>
+            <a:off x="640080" y="1325880"/>
             <a:ext cx="10972800" cy="914400"/>
           </a:xfrm>
           <a:prstGeom prst="rect">
@@ -3490,12 +4062,12 @@
           <a:lstStyle/>
           <a:p>
             <a:r>
-              <a:rPr sz="1800">
+              <a:rPr sz="1600">
                 <a:solidFill>
                   <a:srgbClr val="64748B"/>
                 </a:solidFill>
               </a:rPr>
-              <a:t>El problema: usar IA sin exponer datos sensibles ni perder control.</a:t>
+              <a:t>Por qué MaestroAI y no «otro ChatGPT».</a:t>
             </a:r>
           </a:p>
         </p:txBody>
@@ -3508,8 +4080,8 @@
         </p:nvSpPr>
         <p:spPr>
           <a:xfrm>
-            <a:off x="731520" y="1645920"/>
-            <a:ext cx="10698480" cy="4754880"/>
+            <a:off x="731520" y="1554480"/>
+            <a:ext cx="10698480" cy="4846320"/>
           </a:xfrm>
           <a:prstGeom prst="rect">
             <a:avLst/>
@@ -3524,61 +4096,46 @@
           <a:p>
             <a:pPr>
               <a:spcAft>
-                <a:spcPts val="800"/>
+                <a:spcPts val="600"/>
               </a:spcAft>
             </a:pPr>
             <a:r>
-              <a:rPr sz="1600">
+              <a:rPr sz="1500">
                 <a:solidFill>
                   <a:srgbClr val="334155"/>
                 </a:solidFill>
               </a:rPr>
-              <a:t>• Plataforma de IA privada y gobernada para empresas en LATAM.</a:t>
+              <a:t>• Las empresas quieren IA pero no pueden exponer datos sensibles ni perder control.</a:t>
             </a:r>
           </a:p>
           <a:p>
             <a:pPr>
               <a:spcAft>
-                <a:spcPts val="800"/>
+                <a:spcPts val="600"/>
               </a:spcAft>
             </a:pPr>
             <a:r>
-              <a:rPr sz="1600">
+              <a:rPr sz="1500">
                 <a:solidFill>
                   <a:srgbClr val="334155"/>
                 </a:solidFill>
               </a:rPr>
-              <a:t>• Clasifica datos, redacta PII y enruta al modelo correcto — todo auditado.</a:t>
+              <a:t>• Los asistentes genéricos no clasifican, no auditan y no respetan políticas por área.</a:t>
             </a:r>
           </a:p>
           <a:p>
             <a:pPr>
               <a:spcAft>
-                <a:spcPts val="800"/>
+                <a:spcPts val="600"/>
               </a:spcAft>
             </a:pPr>
             <a:r>
-              <a:rPr sz="1600">
+              <a:rPr sz="1500">
                 <a:solidFill>
                   <a:srgbClr val="334155"/>
                 </a:solidFill>
               </a:rPr>
-              <a:t>• RAG documental por área + casos de uso verticales + automatizaciones.</a:t>
-            </a:r>
-          </a:p>
-          <a:p>
-            <a:pPr>
-              <a:spcAft>
-                <a:spcPts val="800"/>
-              </a:spcAft>
-            </a:pPr>
-            <a:r>
-              <a:rPr sz="1600">
-                <a:solidFill>
-                  <a:srgbClr val="334155"/>
-                </a:solidFill>
-              </a:rPr>
-              <a:t>• Integra las herramientas de la empresa (Google/Microsoft, CRM/ERP, n8n).</a:t>
+              <a:t>• Falta trazabilidad, gobierno de costo y soberanía de datos (LFPDPPP).</a:t>
             </a:r>
           </a:p>
         </p:txBody>
@@ -3609,7 +4166,7 @@
         </p:nvSpPr>
         <p:spPr>
           <a:xfrm>
-            <a:off x="640080" y="457200"/>
+            <a:off x="640080" y="411480"/>
             <a:ext cx="10972800" cy="1097280"/>
           </a:xfrm>
           <a:prstGeom prst="rect">
@@ -3618,18 +4175,18 @@
           <a:noFill/>
         </p:spPr>
         <p:txBody>
-          <a:bodyPr wrap="square">
+          <a:bodyPr wrap="none">
             <a:spAutoFit/>
           </a:bodyPr>
           <a:lstStyle/>
           <a:p>
             <a:r>
-              <a:rPr sz="3000" b="1">
+              <a:rPr sz="2800" b="1">
                 <a:solidFill>
                   <a:srgbClr val="6D28D9"/>
                 </a:solidFill>
               </a:rPr>
-              <a:t>Arquitectura</a:t>
+              <a:t>La propuesta</a:t>
             </a:r>
           </a:p>
         </p:txBody>
@@ -3642,8 +4199,8 @@
         </p:nvSpPr>
         <p:spPr>
           <a:xfrm>
-            <a:off x="731520" y="1645920"/>
-            <a:ext cx="10698480" cy="4754880"/>
+            <a:off x="731520" y="1554480"/>
+            <a:ext cx="10698480" cy="4846320"/>
           </a:xfrm>
           <a:prstGeom prst="rect">
             <a:avLst/>
@@ -3658,91 +4215,93 @@
           <a:p>
             <a:pPr>
               <a:spcAft>
-                <a:spcPts val="800"/>
+                <a:spcPts val="600"/>
               </a:spcAft>
             </a:pPr>
             <a:r>
-              <a:rPr sz="1600">
+              <a:rPr b="1" sz="1500">
                 <a:solidFill>
                   <a:srgbClr val="334155"/>
                 </a:solidFill>
               </a:rPr>
-              <a:t>• Portal (Next.js 15 + Tailwind) en Vercel.</a:t>
+              <a:t>Capa privada y gobernada: </a:t>
+            </a:r>
+            <a:r>
+              <a:rPr sz="1300">
+                <a:solidFill>
+                  <a:srgbClr val="64748B"/>
+                </a:solidFill>
+              </a:rPr>
+              <a:t>sobre cualquier modelo.</a:t>
             </a:r>
           </a:p>
           <a:p>
             <a:pPr>
               <a:spcAft>
-                <a:spcPts val="800"/>
+                <a:spcPts val="600"/>
               </a:spcAft>
             </a:pPr>
             <a:r>
-              <a:rPr sz="1600">
+              <a:rPr b="1" sz="1500">
                 <a:solidFill>
                   <a:srgbClr val="334155"/>
                 </a:solidFill>
               </a:rPr>
-              <a:t>• API (FastAPI + SQLModel) en Render; Postgres en producción.</a:t>
+              <a:t>Enrutador de Privacidad: </a:t>
+            </a:r>
+            <a:r>
+              <a:rPr sz="1300">
+                <a:solidFill>
+                  <a:srgbClr val="64748B"/>
+                </a:solidFill>
+              </a:rPr>
+              <a:t>clasifica, redacta y decide la ruta por cada dato.</a:t>
             </a:r>
           </a:p>
           <a:p>
             <a:pPr>
               <a:spcAft>
-                <a:spcPts val="800"/>
+                <a:spcPts val="600"/>
               </a:spcAft>
             </a:pPr>
             <a:r>
-              <a:rPr sz="1600">
+              <a:rPr b="1" sz="1500">
                 <a:solidFill>
                   <a:srgbClr val="334155"/>
                 </a:solidFill>
               </a:rPr>
-              <a:t>• Router de privacidad: clasifica datos, redacta PII y decide la ruta del modelo — todo auditado.</a:t>
+              <a:t>RAG por área: </a:t>
+            </a:r>
+            <a:r>
+              <a:rPr sz="1300">
+                <a:solidFill>
+                  <a:srgbClr val="64748B"/>
+                </a:solidFill>
+              </a:rPr>
+              <a:t>respuestas con fuentes citadas y permisos.</a:t>
             </a:r>
           </a:p>
           <a:p>
             <a:pPr>
               <a:spcAft>
-                <a:spcPts val="800"/>
+                <a:spcPts val="600"/>
               </a:spcAft>
             </a:pPr>
             <a:r>
-              <a:rPr sz="1600">
+              <a:rPr b="1" sz="1500">
                 <a:solidFill>
                   <a:srgbClr val="334155"/>
                 </a:solidFill>
               </a:rPr>
-              <a:t>• RAG: chunking + embeddings (cifrados) + reranking (NaN) → citas.</a:t>
-            </a:r>
-          </a:p>
-          <a:p>
-            <a:pPr>
-              <a:spcAft>
-                <a:spcPts val="800"/>
-              </a:spcAft>
-            </a:pPr>
-            <a:r>
-              <a:rPr sz="1600">
-                <a:solidFill>
-                  <a:srgbClr val="334155"/>
-                </a:solidFill>
-              </a:rPr>
-              <a:t>• Credenciales cifradas en reposo (AES-256-GCM por tenant).</a:t>
-            </a:r>
-          </a:p>
-          <a:p>
-            <a:pPr>
-              <a:spcAft>
-                <a:spcPts val="800"/>
-              </a:spcAft>
-            </a:pPr>
-            <a:r>
-              <a:rPr sz="1600">
-                <a:solidFill>
-                  <a:srgbClr val="334155"/>
-                </a:solidFill>
-              </a:rPr>
-              <a:t>• CI/CD: GitHub Actions (pytest + build) con compuerta dev → qa → main.</a:t>
+              <a:t>Integraciones: </a:t>
+            </a:r>
+            <a:r>
+              <a:rPr sz="1300">
+                <a:solidFill>
+                  <a:srgbClr val="64748B"/>
+                </a:solidFill>
+              </a:rPr>
+              <a:t>Google/Microsoft, CRM/ERP, n8n, BD/CSV.</a:t>
             </a:r>
           </a:p>
         </p:txBody>
@@ -3773,7 +4332,7 @@
         </p:nvSpPr>
         <p:spPr>
           <a:xfrm>
-            <a:off x="640080" y="457200"/>
+            <a:off x="640080" y="411480"/>
             <a:ext cx="10972800" cy="1097280"/>
           </a:xfrm>
           <a:prstGeom prst="rect">
@@ -3782,18 +4341,18 @@
           <a:noFill/>
         </p:spPr>
         <p:txBody>
-          <a:bodyPr wrap="square">
+          <a:bodyPr wrap="none">
             <a:spAutoFit/>
           </a:bodyPr>
           <a:lstStyle/>
           <a:p>
             <a:r>
-              <a:rPr sz="3000" b="1">
+              <a:rPr sz="2800" b="1">
                 <a:solidFill>
                   <a:srgbClr val="6D28D9"/>
                 </a:solidFill>
               </a:rPr>
-              <a:t>Funcionalidades (1/2)</a:t>
+              <a:t>Arquitectura</a:t>
             </a:r>
           </a:p>
         </p:txBody>
@@ -3806,8 +4365,8 @@
         </p:nvSpPr>
         <p:spPr>
           <a:xfrm>
-            <a:off x="731520" y="1645920"/>
-            <a:ext cx="10698480" cy="4754880"/>
+            <a:off x="731520" y="1554480"/>
+            <a:ext cx="10698480" cy="4846320"/>
           </a:xfrm>
           <a:prstGeom prst="rect">
             <a:avLst/>
@@ -3822,116 +4381,116 @@
           <a:p>
             <a:pPr>
               <a:spcAft>
-                <a:spcPts val="800"/>
+                <a:spcPts val="600"/>
               </a:spcAft>
             </a:pPr>
             <a:r>
-              <a:rPr b="1" sz="1600">
+              <a:rPr b="1" sz="1500">
                 <a:solidFill>
                   <a:srgbClr val="334155"/>
                 </a:solidFill>
               </a:rPr>
-              <a:t>Correo y cuentas: </a:t>
-            </a:r>
-            <a:r>
-              <a:rPr sz="1400">
+              <a:t>Portal: </a:t>
+            </a:r>
+            <a:r>
+              <a:rPr sz="1300">
                 <a:solidFill>
                   <a:srgbClr val="64748B"/>
                 </a:solidFill>
               </a:rPr>
-              <a:t>OAuth Outlook/Gmail + IMAP; varias cuentas por proveedor; caso «Resumen de correo y agenda».</a:t>
+              <a:t>Next.js 15 + Tailwind en Vercel (PWA).</a:t>
             </a:r>
           </a:p>
           <a:p>
             <a:pPr>
               <a:spcAft>
-                <a:spcPts val="800"/>
+                <a:spcPts val="600"/>
               </a:spcAft>
             </a:pPr>
             <a:r>
-              <a:rPr b="1" sz="1600">
+              <a:rPr b="1" sz="1500">
                 <a:solidFill>
                   <a:srgbClr val="334155"/>
                 </a:solidFill>
               </a:rPr>
-              <a:t>Documentos y RAG: </a:t>
-            </a:r>
-            <a:r>
-              <a:rPr sz="1400">
+              <a:t>API: </a:t>
+            </a:r>
+            <a:r>
+              <a:rPr sz="1300">
                 <a:solidFill>
                   <a:srgbClr val="64748B"/>
                 </a:solidFill>
               </a:rPr>
-              <a:t>Repositorio por área + categorías; tratamiento (público/interno/confidencial/restringido) auto-detectado; borrar y re-etiquetar; Google Drive como contexto; índice cifrado.</a:t>
+              <a:t>FastAPI + SQLModel en Render; Postgres (Supabase).</a:t>
             </a:r>
           </a:p>
           <a:p>
             <a:pPr>
               <a:spcAft>
-                <a:spcPts val="800"/>
+                <a:spcPts val="600"/>
               </a:spcAft>
             </a:pPr>
             <a:r>
-              <a:rPr b="1" sz="1600">
+              <a:rPr b="1" sz="1500">
                 <a:solidFill>
                   <a:srgbClr val="334155"/>
                 </a:solidFill>
               </a:rPr>
-              <a:t>Casos de uso (recetas): </a:t>
-            </a:r>
-            <a:r>
-              <a:rPr sz="1400">
+              <a:t>RAG: </a:t>
+            </a:r>
+            <a:r>
+              <a:rPr sz="1300">
                 <a:solidFill>
                   <a:srgbClr val="64748B"/>
                 </a:solidFill>
               </a:rPr>
-              <a:t>Paso universal objetivo/notas/formato; grounding por categoría; reporte por industria; export PDF/Word/Markdown/PPTX/XLSX.</a:t>
+              <a:t>embeddings cifrados + reranking + citas.</a:t>
             </a:r>
           </a:p>
           <a:p>
             <a:pPr>
               <a:spcAft>
-                <a:spcPts val="800"/>
+                <a:spcPts val="600"/>
               </a:spcAft>
             </a:pPr>
             <a:r>
-              <a:rPr b="1" sz="1600">
+              <a:rPr b="1" sz="1500">
                 <a:solidFill>
                   <a:srgbClr val="334155"/>
                 </a:solidFill>
               </a:rPr>
-              <a:t>Chat y Notebooks: </a:t>
-            </a:r>
-            <a:r>
-              <a:rPr sz="1400">
+              <a:t>Modelos: </a:t>
+            </a:r>
+            <a:r>
+              <a:rPr sz="1300">
                 <a:solidFill>
                   <a:srgbClr val="64748B"/>
                 </a:solidFill>
               </a:rPr>
-              <a:t>Chat con 3 modos de contexto (sin contexto / todo / elegir); Notebooks estilo NotebookLM con citas y artefactos.</a:t>
+              <a:t>local (Ollama) · VPC (vLLM) · open (NaN) · premium.</a:t>
             </a:r>
           </a:p>
           <a:p>
             <a:pPr>
               <a:spcAft>
-                <a:spcPts val="800"/>
+                <a:spcPts val="600"/>
               </a:spcAft>
             </a:pPr>
             <a:r>
-              <a:rPr b="1" sz="1600">
+              <a:rPr b="1" sz="1500">
                 <a:solidFill>
                   <a:srgbClr val="334155"/>
                 </a:solidFill>
               </a:rPr>
-              <a:t>Modelos (router de privacidad): </a:t>
-            </a:r>
-            <a:r>
-              <a:rPr sz="1400">
+              <a:t>CI/CD: </a:t>
+            </a:r>
+            <a:r>
+              <a:rPr sz="1300">
                 <a:solidFill>
                   <a:srgbClr val="64748B"/>
                 </a:solidFill>
               </a:rPr>
-              <a:t>Clasifica sensibilidad + PII y enruta local/VPC/abierto(NaN)/premium/bloqueo. NaN-primero; premium solo como escalada a demanda. Reranking del RAG para precisión.</a:t>
+              <a:t>dev → qa → main con pytest + build.</a:t>
             </a:r>
           </a:p>
         </p:txBody>
@@ -3962,7 +4521,7 @@
         </p:nvSpPr>
         <p:spPr>
           <a:xfrm>
-            <a:off x="640080" y="457200"/>
+            <a:off x="640080" y="411480"/>
             <a:ext cx="10972800" cy="1097280"/>
           </a:xfrm>
           <a:prstGeom prst="rect">
@@ -3971,18 +4530,18 @@
           <a:noFill/>
         </p:spPr>
         <p:txBody>
-          <a:bodyPr wrap="square">
+          <a:bodyPr wrap="none">
             <a:spAutoFit/>
           </a:bodyPr>
           <a:lstStyle/>
           <a:p>
             <a:r>
-              <a:rPr sz="3000" b="1">
+              <a:rPr sz="2800" b="1">
                 <a:solidFill>
                   <a:srgbClr val="6D28D9"/>
                 </a:solidFill>
               </a:rPr>
-              <a:t>Funcionalidades (2/2)</a:t>
+              <a:t>Enrutador de Privacidad</a:t>
             </a:r>
           </a:p>
         </p:txBody>
@@ -3995,8 +4554,8 @@
         </p:nvSpPr>
         <p:spPr>
           <a:xfrm>
-            <a:off x="731520" y="1645920"/>
-            <a:ext cx="10698480" cy="4754880"/>
+            <a:off x="640080" y="1325880"/>
+            <a:ext cx="10972800" cy="914400"/>
           </a:xfrm>
           <a:prstGeom prst="rect">
             <a:avLst/>
@@ -4004,6 +4563,39 @@
           <a:noFill/>
         </p:spPr>
         <p:txBody>
+          <a:bodyPr wrap="none">
+            <a:spAutoFit/>
+          </a:bodyPr>
+          <a:lstStyle/>
+          <a:p>
+            <a:r>
+              <a:rPr sz="1600">
+                <a:solidFill>
+                  <a:srgbClr val="64748B"/>
+                </a:solidFill>
+              </a:rPr>
+              <a:t>El usuario nunca elige el modelo: lo decide la política.</a:t>
+            </a:r>
+          </a:p>
+        </p:txBody>
+      </p:sp>
+      <p:sp>
+        <p:nvSpPr>
+          <p:cNvPr id="4" name="TextBox 3"/>
+          <p:cNvSpPr txBox="1"/>
+          <p:nvPr/>
+        </p:nvSpPr>
+        <p:spPr>
+          <a:xfrm>
+            <a:off x="731520" y="1554480"/>
+            <a:ext cx="10698480" cy="4846320"/>
+          </a:xfrm>
+          <a:prstGeom prst="rect">
+            <a:avLst/>
+          </a:prstGeom>
+          <a:noFill/>
+        </p:spPr>
+        <p:txBody>
           <a:bodyPr wrap="square">
             <a:spAutoFit/>
           </a:bodyPr>
@@ -4011,116 +4603,93 @@
           <a:p>
             <a:pPr>
               <a:spcAft>
-                <a:spcPts val="800"/>
+                <a:spcPts val="600"/>
               </a:spcAft>
             </a:pPr>
             <a:r>
-              <a:rPr b="1" sz="1600">
+              <a:rPr b="1" sz="1500">
                 <a:solidFill>
                   <a:srgbClr val="334155"/>
                 </a:solidFill>
               </a:rPr>
-              <a:t>Eficiencia de tokens: </a:t>
-            </a:r>
-            <a:r>
-              <a:rPr sz="1400">
+              <a:t>Restringido: </a:t>
+            </a:r>
+            <a:r>
+              <a:rPr sz="1300">
                 <a:solidFill>
                   <a:srgbClr val="64748B"/>
                 </a:solidFill>
               </a:rPr>
-              <a:t>Condensa contexto grande con el modelo barato antes de premium; tope de gasto por consulta; ahorro acumulado.</a:t>
+              <a:t>Local, nunca sale.</a:t>
             </a:r>
           </a:p>
           <a:p>
             <a:pPr>
               <a:spcAft>
-                <a:spcPts val="800"/>
+                <a:spcPts val="600"/>
               </a:spcAft>
             </a:pPr>
             <a:r>
-              <a:rPr b="1" sz="1600">
+              <a:rPr b="1" sz="1500">
                 <a:solidFill>
                   <a:srgbClr val="334155"/>
                 </a:solidFill>
               </a:rPr>
-              <a:t>Toolkit de acciones: </a:t>
-            </a:r>
-            <a:r>
-              <a:rPr sz="1400">
+              <a:t>Confidencial / PII: </a:t>
+            </a:r>
+            <a:r>
+              <a:rPr sz="1300">
                 <a:solidFill>
                   <a:srgbClr val="64748B"/>
                 </a:solidFill>
               </a:rPr>
-              <a:t>Gmail/Outlook (enviar), Calendar, Sheets/Excel (append), Teams, SharePoint search, OneDrive, lecturas. Aprobación humana + «Permitir siempre».</a:t>
+              <a:t>VPC o local.</a:t>
             </a:r>
           </a:p>
           <a:p>
             <a:pPr>
               <a:spcAft>
-                <a:spcPts val="800"/>
+                <a:spcPts val="600"/>
               </a:spcAft>
             </a:pPr>
             <a:r>
-              <a:rPr b="1" sz="1600">
+              <a:rPr b="1" sz="1500">
                 <a:solidFill>
                   <a:srgbClr val="334155"/>
                 </a:solidFill>
               </a:rPr>
-              <a:t>Imágenes (texto→imagen): </a:t>
-            </a:r>
-            <a:r>
-              <a:rPr sz="1400">
+              <a:t>Interno / Público: </a:t>
+            </a:r>
+            <a:r>
+              <a:rPr sz="1300">
                 <a:solidFill>
                   <a:srgbClr val="64748B"/>
                 </a:solidFill>
               </a:rPr>
-              <a:t>Sección Generar imágenes (ruta estándar OpenAI); galería por área; PII redactada; auditada.</a:t>
+              <a:t>NaN (open); premium a demanda.</a:t>
             </a:r>
           </a:p>
           <a:p>
             <a:pPr>
               <a:spcAft>
-                <a:spcPts val="800"/>
+                <a:spcPts val="600"/>
               </a:spcAft>
             </a:pPr>
             <a:r>
-              <a:rPr b="1" sz="1600">
+              <a:rPr b="1" sz="1500">
                 <a:solidFill>
                   <a:srgbClr val="334155"/>
                 </a:solidFill>
               </a:rPr>
-              <a:t>Integraciones legadas: </a:t>
-            </a:r>
-            <a:r>
-              <a:rPr sz="1400">
+              <a:t>Inyección/exfiltración: </a:t>
+            </a:r>
+            <a:r>
+              <a:rPr sz="1300">
                 <a:solidFill>
                   <a:srgbClr val="64748B"/>
                 </a:solidFill>
               </a:rPr>
-              <a:t>Conectores REST de salida (CRM/ERP) con «ojito» de secretos; Webhooks firmados; BD de solo lectura y CSV → RAG; n8n para el resto.</a:t>
-            </a:r>
-          </a:p>
-          <a:p>
-            <a:pPr>
-              <a:spcAft>
-                <a:spcPts val="800"/>
-              </a:spcAft>
-            </a:pPr>
-            <a:r>
-              <a:rPr b="1" sz="1600">
-                <a:solidFill>
-                  <a:srgbClr val="334155"/>
-                </a:solidFill>
-              </a:rPr>
-              <a:t>Gobernanza y visibilidad: </a:t>
-            </a:r>
-            <a:r>
-              <a:rPr sz="1400">
-                <a:solidFill>
-                  <a:srgbClr val="64748B"/>
-                </a:solidFill>
-              </a:rPr>
-              <a:t>Super admin (multi-tenant) + permisos por área y licencia; flujogramas navegables; dashboard + auditoría navegable; Ayuda in-app en español.</a:t>
+              <a:t>Bloqueado y auditado.</a:t>
             </a:r>
           </a:p>
         </p:txBody>
@@ -4151,7 +4720,7 @@
         </p:nvSpPr>
         <p:spPr>
           <a:xfrm>
-            <a:off x="640080" y="457200"/>
+            <a:off x="640080" y="411480"/>
             <a:ext cx="10972800" cy="1097280"/>
           </a:xfrm>
           <a:prstGeom prst="rect">
@@ -4160,18 +4729,18 @@
           <a:noFill/>
         </p:spPr>
         <p:txBody>
-          <a:bodyPr wrap="square">
+          <a:bodyPr wrap="none">
             <a:spAutoFit/>
           </a:bodyPr>
           <a:lstStyle/>
           <a:p>
             <a:r>
-              <a:rPr sz="3000" b="1">
+              <a:rPr sz="2800" b="1">
                 <a:solidFill>
                   <a:srgbClr val="6D28D9"/>
                 </a:solidFill>
               </a:rPr>
-              <a:t>Gobernanza y privacidad</a:t>
+              <a:t>NaN-primero + cascada</a:t>
             </a:r>
           </a:p>
         </p:txBody>
@@ -4184,8 +4753,8 @@
         </p:nvSpPr>
         <p:spPr>
           <a:xfrm>
-            <a:off x="640080" y="1463040"/>
-            <a:ext cx="10972800" cy="914400"/>
+            <a:off x="731520" y="1554480"/>
+            <a:ext cx="10698480" cy="4846320"/>
           </a:xfrm>
           <a:prstGeom prst="rect">
             <a:avLst/>
@@ -4193,39 +4762,6 @@
           <a:noFill/>
         </p:spPr>
         <p:txBody>
-          <a:bodyPr wrap="none">
-            <a:spAutoFit/>
-          </a:bodyPr>
-          <a:lstStyle/>
-          <a:p>
-            <a:r>
-              <a:rPr sz="1800">
-                <a:solidFill>
-                  <a:srgbClr val="64748B"/>
-                </a:solidFill>
-              </a:rPr>
-              <a:t>El usuario nunca elige el modelo: lo decide la política.</a:t>
-            </a:r>
-          </a:p>
-        </p:txBody>
-      </p:sp>
-      <p:sp>
-        <p:nvSpPr>
-          <p:cNvPr id="4" name="TextBox 3"/>
-          <p:cNvSpPr txBox="1"/>
-          <p:nvPr/>
-        </p:nvSpPr>
-        <p:spPr>
-          <a:xfrm>
-            <a:off x="731520" y="1645920"/>
-            <a:ext cx="10698480" cy="4754880"/>
-          </a:xfrm>
-          <a:prstGeom prst="rect">
-            <a:avLst/>
-          </a:prstGeom>
-          <a:noFill/>
-        </p:spPr>
-        <p:txBody>
           <a:bodyPr wrap="square">
             <a:spAutoFit/>
           </a:bodyPr>
@@ -4233,76 +4769,93 @@
           <a:p>
             <a:pPr>
               <a:spcAft>
-                <a:spcPts val="800"/>
+                <a:spcPts val="600"/>
               </a:spcAft>
             </a:pPr>
             <a:r>
-              <a:rPr sz="1600">
+              <a:rPr b="1" sz="1500">
                 <a:solidFill>
                   <a:srgbClr val="334155"/>
                 </a:solidFill>
               </a:rPr>
-              <a:t>• Datos RESTRICTED → local, nunca salen.</a:t>
+              <a:t>Inicio: </a:t>
+            </a:r>
+            <a:r>
+              <a:rPr sz="1300">
+                <a:solidFill>
+                  <a:srgbClr val="64748B"/>
+                </a:solidFill>
+              </a:rPr>
+              <a:t>datos no sensibles empiezan en NaN (barato/rápido).</a:t>
             </a:r>
           </a:p>
           <a:p>
             <a:pPr>
               <a:spcAft>
-                <a:spcPts val="800"/>
+                <a:spcPts val="600"/>
               </a:spcAft>
             </a:pPr>
             <a:r>
-              <a:rPr sz="1600">
+              <a:rPr b="1" sz="1500">
                 <a:solidFill>
                   <a:srgbClr val="334155"/>
                 </a:solidFill>
               </a:rPr>
-              <a:t>• CONFIDENTIAL → VPC privada (o local si no hay VPC).</a:t>
+              <a:t>Escalada: </a:t>
+            </a:r>
+            <a:r>
+              <a:rPr sz="1300">
+                <a:solidFill>
+                  <a:srgbClr val="64748B"/>
+                </a:solidFill>
+              </a:rPr>
+              <a:t>premium solo con «máxima precisión» o si la respuesta es insuficiente.</a:t>
             </a:r>
           </a:p>
           <a:p>
             <a:pPr>
               <a:spcAft>
-                <a:spcPts val="800"/>
+                <a:spcPts val="600"/>
               </a:spcAft>
             </a:pPr>
             <a:r>
-              <a:rPr sz="1600">
+              <a:rPr b="1" sz="1500">
                 <a:solidFill>
                   <a:srgbClr val="334155"/>
                 </a:solidFill>
               </a:rPr>
-              <a:t>• PII sin alta sensibilidad → nunca a externo por defecto.</a:t>
+              <a:t>Sin premium: </a:t>
+            </a:r>
+            <a:r>
+              <a:rPr sz="1300">
+                <a:solidFill>
+                  <a:srgbClr val="64748B"/>
+                </a:solidFill>
+              </a:rPr>
+              <a:t>todo en NaN; sin NaN, modo demostración.</a:t>
             </a:r>
           </a:p>
           <a:p>
             <a:pPr>
               <a:spcAft>
-                <a:spcPts val="800"/>
+                <a:spcPts val="600"/>
               </a:spcAft>
             </a:pPr>
             <a:r>
-              <a:rPr sz="1600">
+              <a:rPr b="1" sz="1500">
                 <a:solidFill>
                   <a:srgbClr val="334155"/>
                 </a:solidFill>
               </a:rPr>
-              <a:t>• No sensible → empieza en NaN (open); premium solo a demanda o si la respuesta es insuficiente.</a:t>
-            </a:r>
-          </a:p>
-          <a:p>
-            <a:pPr>
-              <a:spcAft>
-                <a:spcPts val="800"/>
-              </a:spcAft>
-            </a:pPr>
-            <a:r>
-              <a:rPr sz="1600">
-                <a:solidFill>
-                  <a:srgbClr val="334155"/>
-                </a:solidFill>
-              </a:rPr>
-              <a:t>• Todo queda auditado con su razón de ruteo.</a:t>
+              <a:t>Eficiencia: </a:t>
+            </a:r>
+            <a:r>
+              <a:rPr sz="1300">
+                <a:solidFill>
+                  <a:srgbClr val="64748B"/>
+                </a:solidFill>
+              </a:rPr>
+              <a:t>condensación + tope de gasto + rerank.</a:t>
             </a:r>
           </a:p>
         </p:txBody>
@@ -4333,7 +4886,7 @@
         </p:nvSpPr>
         <p:spPr>
           <a:xfrm>
-            <a:off x="640080" y="457200"/>
+            <a:off x="640080" y="411480"/>
             <a:ext cx="10972800" cy="1097280"/>
           </a:xfrm>
           <a:prstGeom prst="rect">
@@ -4342,18 +4895,18 @@
           <a:noFill/>
         </p:spPr>
         <p:txBody>
-          <a:bodyPr wrap="square">
+          <a:bodyPr wrap="none">
             <a:spAutoFit/>
           </a:bodyPr>
           <a:lstStyle/>
           <a:p>
             <a:r>
-              <a:rPr sz="3000" b="1">
+              <a:rPr sz="2800" b="1">
                 <a:solidFill>
                   <a:srgbClr val="6D28D9"/>
                 </a:solidFill>
               </a:rPr>
-              <a:t>Modelos · NaN-primero</a:t>
+              <a:t>Módulos funcionales (1/2)</a:t>
             </a:r>
           </a:p>
         </p:txBody>
@@ -4366,8 +4919,8 @@
         </p:nvSpPr>
         <p:spPr>
           <a:xfrm>
-            <a:off x="731520" y="1645920"/>
-            <a:ext cx="10698480" cy="4754880"/>
+            <a:off x="731520" y="1554480"/>
+            <a:ext cx="10698480" cy="4846320"/>
           </a:xfrm>
           <a:prstGeom prst="rect">
             <a:avLst/>
@@ -4382,116 +4935,139 @@
           <a:p>
             <a:pPr>
               <a:spcAft>
-                <a:spcPts val="800"/>
+                <a:spcPts val="600"/>
               </a:spcAft>
             </a:pPr>
             <a:r>
-              <a:rPr b="1" sz="1600">
+              <a:rPr b="1" sz="1500">
                 <a:solidFill>
                   <a:srgbClr val="334155"/>
                 </a:solidFill>
               </a:rPr>
-              <a:t>Inicio: </a:t>
-            </a:r>
-            <a:r>
-              <a:rPr sz="1400">
+              <a:t>Casos de uso (recetas): </a:t>
+            </a:r>
+            <a:r>
+              <a:rPr sz="1300">
                 <a:solidFill>
                   <a:srgbClr val="64748B"/>
                 </a:solidFill>
               </a:rPr>
-              <a:t>Datos no sensibles empiezan en NaN (open), barato y rápido.</a:t>
+              <a:t>Genera entregables (propuestas, cartas, reportes, licitaciones) con un paso universal objetivo/notas/formato y grounding por categoría. Borrador → aprobar → exportar a Word/PDF/Markdown/PPTX/XLSX. Reporte por industria con plantillas por sector.</a:t>
             </a:r>
           </a:p>
           <a:p>
             <a:pPr>
               <a:spcAft>
-                <a:spcPts val="800"/>
+                <a:spcPts val="600"/>
               </a:spcAft>
             </a:pPr>
             <a:r>
-              <a:rPr b="1" sz="1600">
+              <a:rPr b="1" sz="1500">
                 <a:solidFill>
                   <a:srgbClr val="334155"/>
                 </a:solidFill>
               </a:rPr>
-              <a:t>Escalada: </a:t>
-            </a:r>
-            <a:r>
-              <a:rPr sz="1400">
+              <a:t>Agentes verticales: </a:t>
+            </a:r>
+            <a:r>
+              <a:rPr sz="1300">
                 <a:solidFill>
                   <a:srgbClr val="64748B"/>
                 </a:solidFill>
               </a:rPr>
-              <a:t>Premium solo a demanda («máxima precisión») o si la respuesta es insuficiente.</a:t>
+              <a:t>Agentes especializados (Document Intelligence, Cyber Diagnostic, Proposal/SOW, Executive Copilot) configurables por área; cada respuesta pasa por el router de privacidad y cita fuentes.</a:t>
             </a:r>
           </a:p>
           <a:p>
             <a:pPr>
               <a:spcAft>
-                <a:spcPts val="800"/>
+                <a:spcPts val="600"/>
               </a:spcAft>
             </a:pPr>
             <a:r>
-              <a:rPr b="1" sz="1600">
+              <a:rPr b="1" sz="1500">
                 <a:solidFill>
                   <a:srgbClr val="334155"/>
                 </a:solidFill>
               </a:rPr>
-              <a:t>Sin premium: </a:t>
-            </a:r>
-            <a:r>
-              <a:rPr sz="1400">
+              <a:t>Chat con fuentes: </a:t>
+            </a:r>
+            <a:r>
+              <a:rPr sz="1300">
                 <a:solidFill>
                   <a:srgbClr val="64748B"/>
                 </a:solidFill>
               </a:rPr>
-              <a:t>Todo corre en NaN; sin NaN, modo demostración (mock).</a:t>
+              <a:t>3 modos de contexto (sin contexto / todo el RAG / elegir documentos), toggles de máxima precisión (cascada) y memoria; banner con clasificación y ruta real; exportable.</a:t>
             </a:r>
           </a:p>
           <a:p>
             <a:pPr>
               <a:spcAft>
-                <a:spcPts val="800"/>
+                <a:spcPts val="600"/>
               </a:spcAft>
             </a:pPr>
             <a:r>
-              <a:rPr b="1" sz="1600">
+              <a:rPr b="1" sz="1500">
                 <a:solidFill>
                   <a:srgbClr val="334155"/>
                 </a:solidFill>
               </a:rPr>
-              <a:t>Precisión: </a:t>
-            </a:r>
-            <a:r>
-              <a:rPr sz="1400">
+              <a:t>Notebooks: </a:t>
+            </a:r>
+            <a:r>
+              <a:rPr sz="1300">
                 <a:solidFill>
                   <a:srgbClr val="64748B"/>
                 </a:solidFill>
               </a:rPr>
-              <a:t>Reranking del RAG (Qwen3-Reranker) reordena por relevancia.</a:t>
+              <a:t>Estilo NotebookLM privado: fuentes + preguntas citadas + artefactos (resumen, FAQ, guía, briefing, cronología) acotados a esos documentos.</a:t>
             </a:r>
           </a:p>
           <a:p>
             <a:pPr>
               <a:spcAft>
-                <a:spcPts val="800"/>
+                <a:spcPts val="600"/>
               </a:spcAft>
             </a:pPr>
             <a:r>
-              <a:rPr b="1" sz="1600">
+              <a:rPr b="1" sz="1500">
                 <a:solidFill>
                   <a:srgbClr val="334155"/>
                 </a:solidFill>
               </a:rPr>
-              <a:t>Eficiencia: </a:t>
-            </a:r>
-            <a:r>
-              <a:rPr sz="1400">
+              <a:t>Documentos y RAG: </a:t>
+            </a:r>
+            <a:r>
+              <a:rPr sz="1300">
                 <a:solidFill>
                   <a:srgbClr val="64748B"/>
                 </a:solidFill>
               </a:rPr>
-              <a:t>Condensación + tope de gasto por consulta.</a:t>
+              <a:t>Repositorio por área + catálogo de categorías; tratamiento auto-detectado (público/interno/confidencial/restringido) y editable; borrar y re-etiquetar; Drive como contexto; índice cifrado.</a:t>
+            </a:r>
+          </a:p>
+          <a:p>
+            <a:pPr>
+              <a:spcAft>
+                <a:spcPts val="600"/>
+              </a:spcAft>
+            </a:pPr>
+            <a:r>
+              <a:rPr b="1" sz="1500">
+                <a:solidFill>
+                  <a:srgbClr val="334155"/>
+                </a:solidFill>
+              </a:rPr>
+              <a:t>Memoria y etiquetas: </a:t>
+            </a:r>
+            <a:r>
+              <a:rPr sz="1300">
+                <a:solidFill>
+                  <a:srgbClr val="64748B"/>
+                </a:solidFill>
+              </a:rPr>
+              <a:t>Memoria persistente de trabajos con búsqueda semántica + por tags; recall en el chat ('¿recuerdas el trabajo C?'); auto-captura al completar casos.</a:t>
             </a:r>
           </a:p>
         </p:txBody>
@@ -4522,7 +5098,7 @@
         </p:nvSpPr>
         <p:spPr>
           <a:xfrm>
-            <a:off x="640080" y="457200"/>
+            <a:off x="640080" y="411480"/>
             <a:ext cx="10972800" cy="1097280"/>
           </a:xfrm>
           <a:prstGeom prst="rect">
@@ -4531,18 +5107,18 @@
           <a:noFill/>
         </p:spPr>
         <p:txBody>
-          <a:bodyPr wrap="square">
+          <a:bodyPr wrap="none">
             <a:spAutoFit/>
           </a:bodyPr>
           <a:lstStyle/>
           <a:p>
             <a:r>
-              <a:rPr sz="3000" b="1">
+              <a:rPr sz="2800" b="1">
                 <a:solidFill>
                   <a:srgbClr val="6D28D9"/>
                 </a:solidFill>
               </a:rPr>
-              <a:t>Entornos y CI/CD</a:t>
+              <a:t>Módulos funcionales (2/2)</a:t>
             </a:r>
           </a:p>
         </p:txBody>
@@ -4555,8 +5131,8 @@
         </p:nvSpPr>
         <p:spPr>
           <a:xfrm>
-            <a:off x="731520" y="1645920"/>
-            <a:ext cx="10698480" cy="4754880"/>
+            <a:off x="731520" y="1554480"/>
+            <a:ext cx="10698480" cy="4846320"/>
           </a:xfrm>
           <a:prstGeom prst="rect">
             <a:avLst/>
@@ -4571,61 +5147,139 @@
           <a:p>
             <a:pPr>
               <a:spcAft>
-                <a:spcPts val="800"/>
+                <a:spcPts val="600"/>
               </a:spcAft>
             </a:pPr>
             <a:r>
-              <a:rPr sz="1600">
+              <a:rPr b="1" sz="1500">
                 <a:solidFill>
                   <a:srgbClr val="334155"/>
                 </a:solidFill>
               </a:rPr>
-              <a:t>• Promoción dev → qa → main (prod).</a:t>
+              <a:t>Generar imágenes: </a:t>
+            </a:r>
+            <a:r>
+              <a:rPr sz="1300">
+                <a:solidFill>
+                  <a:srgbClr val="64748B"/>
+                </a:solidFill>
+              </a:rPr>
+              <a:t>Texto→imagen (ruta estándar OpenAI), relación de aspecto y variantes; galería por área; PII redactada; auditada.</a:t>
             </a:r>
           </a:p>
           <a:p>
             <a:pPr>
               <a:spcAft>
-                <a:spcPts val="800"/>
+                <a:spcPts val="600"/>
               </a:spcAft>
             </a:pPr>
             <a:r>
-              <a:rPr sz="1600">
+              <a:rPr b="1" sz="1500">
                 <a:solidFill>
                   <a:srgbClr val="334155"/>
                 </a:solidFill>
               </a:rPr>
-              <a:t>• CI obligatorio: pytest (API) + build (portal).</a:t>
+              <a:t>Flujogramas: </a:t>
+            </a:r>
+            <a:r>
+              <a:rPr sz="1300">
+                <a:solidFill>
+                  <a:srgbClr val="64748B"/>
+                </a:solidFill>
+              </a:rPr>
+              <a:t>La lógica del producto navegable: los flujos base del blueprint + flujo de caso + diseño libre.</a:t>
             </a:r>
           </a:p>
           <a:p>
             <a:pPr>
               <a:spcAft>
-                <a:spcPts val="800"/>
+                <a:spcPts val="600"/>
               </a:spcAft>
             </a:pPr>
             <a:r>
-              <a:rPr sz="1600">
+              <a:rPr b="1" sz="1500">
                 <a:solidFill>
                   <a:srgbClr val="334155"/>
                 </a:solidFill>
               </a:rPr>
-              <a:t>• Despliegue: Vercel (portal) + Render (API).</a:t>
+              <a:t>Tableros: </a:t>
+            </a:r>
+            <a:r>
+              <a:rPr sz="1300">
+                <a:solidFill>
+                  <a:srgbClr val="64748B"/>
+                </a:solidFill>
+              </a:rPr>
+              <a:t>Dashboards a la medida: describe qué medir, agrega KPIs y gráficas en vivo (tokens por fuente, casos por receta, costo por ruta) + KPIs manuales.</a:t>
             </a:r>
           </a:p>
           <a:p>
             <a:pPr>
               <a:spcAft>
-                <a:spcPts val="800"/>
+                <a:spcPts val="600"/>
               </a:spcAft>
             </a:pPr>
             <a:r>
-              <a:rPr sz="1600">
+              <a:rPr b="1" sz="1500">
                 <a:solidFill>
                   <a:srgbClr val="334155"/>
                 </a:solidFill>
               </a:rPr>
-              <a:t>• Migraciones aditivas idempotentes (sin pérdida de datos).</a:t>
+              <a:t>Trámites y casos (MCP): </a:t>
+            </a:r>
+            <a:r>
+              <a:rPr sz="1300">
+                <a:solidFill>
+                  <a:srgbClr val="64748B"/>
+                </a:solidFill>
+              </a:rPr>
+              <a:t>Catálogo curado por país/estado/empresa por ejes de desarrollo; convierte un trámite en propuesta de caso; aterriza (grounding) las respuestas.</a:t>
+            </a:r>
+          </a:p>
+          <a:p>
+            <a:pPr>
+              <a:spcAft>
+                <a:spcPts val="600"/>
+              </a:spcAft>
+            </a:pPr>
+            <a:r>
+              <a:rPr b="1" sz="1500">
+                <a:solidFill>
+                  <a:srgbClr val="334155"/>
+                </a:solidFill>
+              </a:rPr>
+              <a:t>App Studio: </a:t>
+            </a:r>
+            <a:r>
+              <a:rPr sz="1300">
+                <a:solidFill>
+                  <a:srgbClr val="64748B"/>
+                </a:solidFill>
+              </a:rPr>
+              <a:t>Construye mini-apps con IA y publícalas (pago por despliegue).</a:t>
+            </a:r>
+          </a:p>
+          <a:p>
+            <a:pPr>
+              <a:spcAft>
+                <a:spcPts val="600"/>
+              </a:spcAft>
+            </a:pPr>
+            <a:r>
+              <a:rPr b="1" sz="1500">
+                <a:solidFill>
+                  <a:srgbClr val="334155"/>
+                </a:solidFill>
+              </a:rPr>
+              <a:t>Automatizaciones: </a:t>
+            </a:r>
+            <a:r>
+              <a:rPr sz="1300">
+                <a:solidFill>
+                  <a:srgbClr val="64748B"/>
+                </a:solidFill>
+              </a:rPr>
+              <a:t>Disparador (manual/programado/evento) → acción (workflow n8n / caso / conector / notificar), con plantillas y ejecución manual.</a:t>
             </a:r>
           </a:p>
         </p:txBody>
@@ -4656,7 +5310,7 @@
         </p:nvSpPr>
         <p:spPr>
           <a:xfrm>
-            <a:off x="640080" y="457200"/>
+            <a:off x="640080" y="411480"/>
             <a:ext cx="10972800" cy="1097280"/>
           </a:xfrm>
           <a:prstGeom prst="rect">
@@ -4665,18 +5319,18 @@
           <a:noFill/>
         </p:spPr>
         <p:txBody>
-          <a:bodyPr wrap="square">
+          <a:bodyPr wrap="none">
             <a:spAutoFit/>
           </a:bodyPr>
           <a:lstStyle/>
           <a:p>
             <a:r>
-              <a:rPr sz="3000" b="1">
+              <a:rPr sz="2800" b="1">
                 <a:solidFill>
                   <a:srgbClr val="6D28D9"/>
                 </a:solidFill>
               </a:rPr>
-              <a:t>Ayuda y operación</a:t>
+              <a:t>Integraciones</a:t>
             </a:r>
           </a:p>
         </p:txBody>
@@ -4689,8 +5343,8 @@
         </p:nvSpPr>
         <p:spPr>
           <a:xfrm>
-            <a:off x="731520" y="1645920"/>
-            <a:ext cx="10698480" cy="4754880"/>
+            <a:off x="731520" y="1554480"/>
+            <a:ext cx="10698480" cy="4846320"/>
           </a:xfrm>
           <a:prstGeom prst="rect">
             <a:avLst/>
@@ -4705,46 +5359,93 @@
           <a:p>
             <a:pPr>
               <a:spcAft>
-                <a:spcPts val="800"/>
+                <a:spcPts val="600"/>
               </a:spcAft>
             </a:pPr>
             <a:r>
-              <a:rPr sz="1600">
+              <a:rPr b="1" sz="1500">
                 <a:solidFill>
                   <a:srgbClr val="334155"/>
                 </a:solidFill>
               </a:rPr>
-              <a:t>• Ayuda in-app en español con guías paso a paso.</a:t>
+              <a:t>Correo: </a:t>
+            </a:r>
+            <a:r>
+              <a:rPr sz="1300">
+                <a:solidFill>
+                  <a:srgbClr val="64748B"/>
+                </a:solidFill>
+              </a:rPr>
+              <a:t>Outlook/Gmail/IMAP, multi-cuenta.</a:t>
             </a:r>
           </a:p>
           <a:p>
             <a:pPr>
               <a:spcAft>
-                <a:spcPts val="800"/>
+                <a:spcPts val="600"/>
               </a:spcAft>
             </a:pPr>
             <a:r>
-              <a:rPr sz="1600">
+              <a:rPr b="1" sz="1500">
                 <a:solidFill>
                   <a:srgbClr val="334155"/>
                 </a:solidFill>
               </a:rPr>
-              <a:t>• Ayuda contextual por sección (botón ? con popup).</a:t>
+              <a:t>Acciones: </a:t>
+            </a:r>
+            <a:r>
+              <a:rPr sz="1300">
+                <a:solidFill>
+                  <a:srgbClr val="64748B"/>
+                </a:solidFill>
+              </a:rPr>
+              <a:t>Gmail/Outlook, Calendar, Sheets/Excel, Teams, SharePoint.</a:t>
             </a:r>
           </a:p>
           <a:p>
             <a:pPr>
               <a:spcAft>
-                <a:spcPts val="800"/>
+                <a:spcPts val="600"/>
               </a:spcAft>
             </a:pPr>
             <a:r>
-              <a:rPr sz="1600">
+              <a:rPr b="1" sz="1500">
                 <a:solidFill>
                   <a:srgbClr val="334155"/>
                 </a:solidFill>
               </a:rPr>
-              <a:t>• Auditoría navegable de cada acción y ruteo.</a:t>
+              <a:t>Conectores/Webhooks: </a:t>
+            </a:r>
+            <a:r>
+              <a:rPr sz="1300">
+                <a:solidFill>
+                  <a:srgbClr val="64748B"/>
+                </a:solidFill>
+              </a:rPr>
+              <a:t>CRM/ERP + HMAC entrante.</a:t>
+            </a:r>
+          </a:p>
+          <a:p>
+            <a:pPr>
+              <a:spcAft>
+                <a:spcPts val="600"/>
+              </a:spcAft>
+            </a:pPr>
+            <a:r>
+              <a:rPr b="1" sz="1500">
+                <a:solidFill>
+                  <a:srgbClr val="334155"/>
+                </a:solidFill>
+              </a:rPr>
+              <a:t>Legados: </a:t>
+            </a:r>
+            <a:r>
+              <a:rPr sz="1300">
+                <a:solidFill>
+                  <a:srgbClr val="64748B"/>
+                </a:solidFill>
+              </a:rPr>
+              <a:t>BD solo lectura y CSV → RAG; n8n para el resto.</a:t>
             </a:r>
           </a:p>
         </p:txBody>

</xml_diff>

<commit_message>
docs: documentación profunda (capacidad/logro/caso/pasos + guías de config)
Reescribe el generador a un manual completo:
- 16 capacidades, cada una con Capacidad · Logro/valor · Caso de uso · Pasos.
- Sección 6: 10 guías técnicas de configuración paso a paso (Microsoft/Google
  OAuth, IMAP, NaN, premium, Ollama, n8n, rerank, proteger ramas, núcleo/Vercel/DB)
  con variables de entorno.
- Apéndices: endpoints y catálogo de acciones. PPT a 22 láminas (una por capacidad).

Co-Authored-By: Claude Opus 4.8 <noreply@anthropic.com>
Claude-Session: https://claude.ai/code/session_01HTAvTHuepv1vkFtVGxRvVu
</commit_message>
<xml_diff>
--- a/docs/generados/MaestroAI-Presentacion.pptx
+++ b/docs/generados/MaestroAI-Presentacion.pptx
@@ -20,6 +20,13 @@
     <p:sldId id="268" r:id="rId19"/>
     <p:sldId id="269" r:id="rId20"/>
     <p:sldId id="270" r:id="rId21"/>
+    <p:sldId id="271" r:id="rId22"/>
+    <p:sldId id="272" r:id="rId23"/>
+    <p:sldId id="273" r:id="rId24"/>
+    <p:sldId id="274" r:id="rId25"/>
+    <p:sldId id="275" r:id="rId26"/>
+    <p:sldId id="276" r:id="rId27"/>
+    <p:sldId id="277" r:id="rId28"/>
   </p:sldIdLst>
   <p:sldSz cx="12191695" cy="6858000" type="screen4x3"/>
   <p:notesSz cx="6858000" cy="9144000"/>
@@ -3133,7 +3140,7 @@
           <a:lstStyle/>
           <a:p>
             <a:r>
-              <a:rPr sz="3800" b="1">
+              <a:rPr sz="3600" b="1">
                 <a:solidFill>
                   <a:srgbClr val="FFFFFF"/>
                 </a:solidFill>
@@ -3166,7 +3173,7 @@
           <a:lstStyle/>
           <a:p>
             <a:r>
-              <a:rPr sz="1600">
+              <a:rPr sz="1500">
                 <a:solidFill>
                   <a:srgbClr val="FFFFFF"/>
                 </a:solidFill>
@@ -3217,12 +3224,12 @@
           <a:lstStyle/>
           <a:p>
             <a:r>
-              <a:rPr sz="2800" b="1">
+              <a:rPr sz="2600" b="1">
                 <a:solidFill>
                   <a:srgbClr val="6D28D9"/>
                 </a:solidFill>
               </a:rPr>
-              <a:t>Modelos de NaN</a:t>
+              <a:t>Chat con fuentes</a:t>
             </a:r>
           </a:p>
         </p:txBody>
@@ -3251,93 +3258,70 @@
           <a:p>
             <a:pPr>
               <a:spcAft>
-                <a:spcPts val="600"/>
+                <a:spcPts val="500"/>
               </a:spcAft>
             </a:pPr>
             <a:r>
-              <a:rPr b="1" sz="1500">
+              <a:rPr b="1" sz="1400">
                 <a:solidFill>
                   <a:srgbClr val="334155"/>
                 </a:solidFill>
               </a:rPr>
-              <a:t>qwen3.6: </a:t>
-            </a:r>
-            <a:r>
-              <a:rPr sz="1300">
+              <a:t>Logro: </a:t>
+            </a:r>
+            <a:r>
+              <a:rPr sz="1200">
                 <a:solidFill>
                   <a:srgbClr val="64748B"/>
                 </a:solidFill>
               </a:rPr>
-              <a:t>principal (chat, tools, visión, reasoning).</a:t>
+              <a:t>Una sola interfaz para preguntar con o sin documentos, con control de precisión y costo, y trazabilidad de cada respuesta.</a:t>
             </a:r>
           </a:p>
           <a:p>
             <a:pPr>
               <a:spcAft>
-                <a:spcPts val="600"/>
+                <a:spcPts val="500"/>
               </a:spcAft>
             </a:pPr>
             <a:r>
-              <a:rPr b="1" sz="1500">
+              <a:rPr b="1" sz="1400">
                 <a:solidFill>
                   <a:srgbClr val="334155"/>
                 </a:solidFill>
               </a:rPr>
-              <a:t>deepseek-v4-flash / mimo-v2.5: </a:t>
-            </a:r>
-            <a:r>
-              <a:rPr sz="1300">
+              <a:t>Caso de uso: </a:t>
+            </a:r>
+            <a:r>
+              <a:rPr sz="1200">
                 <a:solidFill>
                   <a:srgbClr val="64748B"/>
                 </a:solidFill>
               </a:rPr>
-              <a:t>1M tokens; mimo omnimodal.</a:t>
+              <a:t>Un usuario activa «elegir documentos», selecciona 3 archivos y pregunta; la respuesta se basa solo en esos, con cita.</a:t>
             </a:r>
           </a:p>
           <a:p>
             <a:pPr>
               <a:spcAft>
-                <a:spcPts val="600"/>
+                <a:spcPts val="500"/>
               </a:spcAft>
             </a:pPr>
             <a:r>
-              <a:rPr b="1" sz="1500">
+              <a:rPr b="1" sz="1400">
                 <a:solidFill>
                   <a:srgbClr val="334155"/>
                 </a:solidFill>
               </a:rPr>
-              <a:t>qwen3-embedding / rerank: </a:t>
-            </a:r>
-            <a:r>
-              <a:rPr sz="1300">
+              <a:t>Cómo: </a:t>
+            </a:r>
+            <a:r>
+              <a:rPr sz="1200">
                 <a:solidFill>
                   <a:srgbClr val="64748B"/>
                 </a:solidFill>
               </a:rPr>
-              <a:t>stack RAG.</a:t>
-            </a:r>
-          </a:p>
-          <a:p>
-            <a:pPr>
-              <a:spcAft>
-                <a:spcPts val="600"/>
-              </a:spcAft>
-            </a:pPr>
-            <a:r>
-              <a:rPr b="1" sz="1500">
-                <a:solidFill>
-                  <a:srgbClr val="334155"/>
-                </a:solidFill>
-              </a:rPr>
-              <a:t>kokoro / whisper: </a:t>
-            </a:r>
-            <a:r>
-              <a:rPr sz="1300">
-                <a:solidFill>
-                  <a:srgbClr val="64748B"/>
-                </a:solidFill>
-              </a:rPr>
-              <a:t>TTS / STT.</a:t>
+              <a:t>Chat con fuentes → elige el modo de contexto. …</a:t>
             </a:r>
           </a:p>
         </p:txBody>
@@ -3383,12 +3367,12 @@
           <a:lstStyle/>
           <a:p>
             <a:r>
-              <a:rPr sz="2800" b="1">
+              <a:rPr sz="2600" b="1">
                 <a:solidFill>
                   <a:srgbClr val="6D28D9"/>
                 </a:solidFill>
               </a:rPr>
-              <a:t>Seguridad y cumplimiento</a:t>
+              <a:t>Notebooks (estilo NotebookLM privado)</a:t>
             </a:r>
           </a:p>
         </p:txBody>
@@ -3417,61 +3401,70 @@
           <a:p>
             <a:pPr>
               <a:spcAft>
-                <a:spcPts val="600"/>
+                <a:spcPts val="500"/>
               </a:spcAft>
             </a:pPr>
             <a:r>
-              <a:rPr sz="1500">
+              <a:rPr b="1" sz="1400">
                 <a:solidFill>
                   <a:srgbClr val="334155"/>
                 </a:solidFill>
               </a:rPr>
-              <a:t>• Cifrado en reposo AES-256-GCM por tenant.</a:t>
+              <a:t>Logro: </a:t>
+            </a:r>
+            <a:r>
+              <a:rPr sz="1200">
+                <a:solidFill>
+                  <a:srgbClr val="64748B"/>
+                </a:solidFill>
+              </a:rPr>
+              <a:t>Estudio profundo de un conjunto de documentos sin que el modelo se «desvíe» a otros, con salidas reutilizables.</a:t>
             </a:r>
           </a:p>
           <a:p>
             <a:pPr>
               <a:spcAft>
-                <a:spcPts val="600"/>
+                <a:spcPts val="500"/>
               </a:spcAft>
             </a:pPr>
             <a:r>
-              <a:rPr sz="1500">
+              <a:rPr b="1" sz="1400">
                 <a:solidFill>
                   <a:srgbClr val="334155"/>
                 </a:solidFill>
               </a:rPr>
-              <a:t>• Redacción de PII y minimización de contexto.</a:t>
+              <a:t>Caso de uso: </a:t>
+            </a:r>
+            <a:r>
+              <a:rPr sz="1200">
+                <a:solidFill>
+                  <a:srgbClr val="64748B"/>
+                </a:solidFill>
+              </a:rPr>
+              <a:t>Para una licitación se crea un notebook con las bases y se genera una FAQ y una cronología.</a:t>
             </a:r>
           </a:p>
           <a:p>
             <a:pPr>
               <a:spcAft>
-                <a:spcPts val="600"/>
+                <a:spcPts val="500"/>
               </a:spcAft>
             </a:pPr>
             <a:r>
-              <a:rPr sz="1500">
+              <a:rPr b="1" sz="1400">
                 <a:solidFill>
                   <a:srgbClr val="334155"/>
                 </a:solidFill>
               </a:rPr>
-              <a:t>• Auditoría total + export a SIEM.</a:t>
-            </a:r>
-          </a:p>
-          <a:p>
-            <a:pPr>
-              <a:spcAft>
-                <a:spcPts val="600"/>
-              </a:spcAft>
-            </a:pPr>
-            <a:r>
-              <a:rPr sz="1500">
-                <a:solidFill>
-                  <a:srgbClr val="334155"/>
-                </a:solidFill>
-              </a:rPr>
-              <a:t>• LFPDPPP · OWASP LLM 2025 · NIST AI RMF.</a:t>
+              <a:t>Cómo: </a:t>
+            </a:r>
+            <a:r>
+              <a:rPr sz="1200">
+                <a:solidFill>
+                  <a:srgbClr val="64748B"/>
+                </a:solidFill>
+              </a:rPr>
+              <a:t>Notebooks → crea uno y añade fuentes del RAG. …</a:t>
             </a:r>
           </a:p>
         </p:txBody>
@@ -3517,12 +3510,12 @@
           <a:lstStyle/>
           <a:p>
             <a:r>
-              <a:rPr sz="2800" b="1">
+              <a:rPr sz="2600" b="1">
                 <a:solidFill>
                   <a:srgbClr val="6D28D9"/>
                 </a:solidFill>
               </a:rPr>
-              <a:t>Roles y gobierno</a:t>
+              <a:t>Memoria y etiquetas</a:t>
             </a:r>
           </a:p>
         </p:txBody>
@@ -3551,70 +3544,70 @@
           <a:p>
             <a:pPr>
               <a:spcAft>
-                <a:spcPts val="600"/>
+                <a:spcPts val="500"/>
               </a:spcAft>
             </a:pPr>
             <a:r>
-              <a:rPr b="1" sz="1500">
+              <a:rPr b="1" sz="1400">
                 <a:solidFill>
                   <a:srgbClr val="334155"/>
                 </a:solidFill>
               </a:rPr>
-              <a:t>super_admin / admin: </a:t>
-            </a:r>
-            <a:r>
-              <a:rPr sz="1300">
+              <a:t>Logro: </a:t>
+            </a:r>
+            <a:r>
+              <a:rPr sz="1200">
                 <a:solidFill>
                   <a:srgbClr val="64748B"/>
                 </a:solidFill>
               </a:rPr>
-              <a:t>multi-tenant / configuración del tenant.</a:t>
+              <a:t>El sistema «recuerda» trabajos previos («¿recuerdas el trabajo C?») y los reutiliza, evitando rehacer y perdiendo menos contexto entre sesiones.</a:t>
             </a:r>
           </a:p>
           <a:p>
             <a:pPr>
               <a:spcAft>
-                <a:spcPts val="600"/>
+                <a:spcPts val="500"/>
               </a:spcAft>
             </a:pPr>
             <a:r>
-              <a:rPr b="1" sz="1500">
+              <a:rPr b="1" sz="1400">
                 <a:solidFill>
                   <a:srgbClr val="334155"/>
                 </a:solidFill>
               </a:rPr>
-              <a:t>user / security / devops: </a:t>
-            </a:r>
-            <a:r>
-              <a:rPr sz="1300">
+              <a:t>Caso de uso: </a:t>
+            </a:r>
+            <a:r>
+              <a:rPr sz="1200">
                 <a:solidFill>
                   <a:srgbClr val="64748B"/>
                 </a:solidFill>
               </a:rPr>
-              <a:t>uso / auditoría / integraciones.</a:t>
+              <a:t>Semanas después, el usuario pide continuar «la propuesta C» y el sistema recupera lo hecho.</a:t>
             </a:r>
           </a:p>
           <a:p>
             <a:pPr>
               <a:spcAft>
-                <a:spcPts val="600"/>
+                <a:spcPts val="500"/>
               </a:spcAft>
             </a:pPr>
             <a:r>
-              <a:rPr b="1" sz="1500">
+              <a:rPr b="1" sz="1400">
                 <a:solidFill>
                   <a:srgbClr val="334155"/>
                 </a:solidFill>
               </a:rPr>
-              <a:t>Permisos por área y licencia: </a:t>
-            </a:r>
-            <a:r>
-              <a:rPr sz="1300">
+              <a:t>Cómo: </a:t>
+            </a:r>
+            <a:r>
+              <a:rPr sz="1200">
                 <a:solidFill>
                   <a:srgbClr val="64748B"/>
                 </a:solidFill>
               </a:rPr>
-              <a:t>cada quien ve lo suyo.</a:t>
+              <a:t>Guarda resultados con «Guardar en memoria» (o se auto-capturan al completar casos). …</a:t>
             </a:r>
           </a:p>
         </p:txBody>
@@ -3660,12 +3653,12 @@
           <a:lstStyle/>
           <a:p>
             <a:r>
-              <a:rPr sz="2800" b="1">
+              <a:rPr sz="2600" b="1">
                 <a:solidFill>
                   <a:srgbClr val="6D28D9"/>
                 </a:solidFill>
               </a:rPr>
-              <a:t>Entornos y operación</a:t>
+              <a:t>Generar imágenes (texto → imagen)</a:t>
             </a:r>
           </a:p>
         </p:txBody>
@@ -3694,61 +3687,70 @@
           <a:p>
             <a:pPr>
               <a:spcAft>
-                <a:spcPts val="600"/>
+                <a:spcPts val="500"/>
               </a:spcAft>
             </a:pPr>
             <a:r>
-              <a:rPr sz="1500">
+              <a:rPr b="1" sz="1400">
                 <a:solidFill>
                   <a:srgbClr val="334155"/>
                 </a:solidFill>
               </a:rPr>
-              <a:t>• dev → qa → main con CI obligatorio.</a:t>
+              <a:t>Logro: </a:t>
+            </a:r>
+            <a:r>
+              <a:rPr sz="1200">
+                <a:solidFill>
+                  <a:srgbClr val="64748B"/>
+                </a:solidFill>
+              </a:rPr>
+              <a:t>Material visual gobernado dentro de la plataforma, con copia propia y permisos por área.</a:t>
             </a:r>
           </a:p>
           <a:p>
             <a:pPr>
               <a:spcAft>
-                <a:spcPts val="600"/>
+                <a:spcPts val="500"/>
               </a:spcAft>
             </a:pPr>
             <a:r>
-              <a:rPr sz="1500">
+              <a:rPr b="1" sz="1400">
                 <a:solidFill>
                   <a:srgbClr val="334155"/>
                 </a:solidFill>
               </a:rPr>
-              <a:t>• Despliegue: Vercel (portal) + Render (API).</a:t>
+              <a:t>Caso de uso: </a:t>
+            </a:r>
+            <a:r>
+              <a:rPr sz="1200">
+                <a:solidFill>
+                  <a:srgbClr val="64748B"/>
+                </a:solidFill>
+              </a:rPr>
+              <a:t>Marketing genera variantes de una imagen para una campaña; quedan en la galería del área.</a:t>
             </a:r>
           </a:p>
           <a:p>
             <a:pPr>
               <a:spcAft>
-                <a:spcPts val="600"/>
+                <a:spcPts val="500"/>
               </a:spcAft>
             </a:pPr>
             <a:r>
-              <a:rPr sz="1500">
+              <a:rPr b="1" sz="1400">
                 <a:solidFill>
                   <a:srgbClr val="334155"/>
                 </a:solidFill>
               </a:rPr>
-              <a:t>• Ayuda in-app + contextual (popup) por sección.</a:t>
-            </a:r>
-          </a:p>
-          <a:p>
-            <a:pPr>
-              <a:spcAft>
-                <a:spcPts val="600"/>
-              </a:spcAft>
-            </a:pPr>
-            <a:r>
-              <a:rPr sz="1500">
-                <a:solidFill>
-                  <a:srgbClr val="334155"/>
-                </a:solidFill>
-              </a:rPr>
-              <a:t>• Auditoría navegable de cada acción.</a:t>
+              <a:t>Cómo: </a:t>
+            </a:r>
+            <a:r>
+              <a:rPr sz="1200">
+                <a:solidFill>
+                  <a:srgbClr val="64748B"/>
+                </a:solidFill>
+              </a:rPr>
+              <a:t>Generar imágenes → escribe el prompt, elige aspecto y variantes. …</a:t>
             </a:r>
           </a:p>
         </p:txBody>
@@ -3794,12 +3796,12 @@
           <a:lstStyle/>
           <a:p>
             <a:r>
-              <a:rPr sz="2800" b="1">
+              <a:rPr sz="2600" b="1">
                 <a:solidFill>
                   <a:srgbClr val="6D28D9"/>
                 </a:solidFill>
               </a:rPr>
-              <a:t>Roadmap</a:t>
+              <a:t>Toolkit de acciones (Google / Microsoft)</a:t>
             </a:r>
           </a:p>
         </p:txBody>
@@ -3828,70 +3830,70 @@
           <a:p>
             <a:pPr>
               <a:spcAft>
-                <a:spcPts val="600"/>
+                <a:spcPts val="500"/>
               </a:spcAft>
             </a:pPr>
             <a:r>
-              <a:rPr b="1" sz="1500">
+              <a:rPr b="1" sz="1400">
                 <a:solidFill>
                   <a:srgbClr val="334155"/>
                 </a:solidFill>
               </a:rPr>
-              <a:t>Catálogos de configuración empresarial: </a:t>
-            </a:r>
-            <a:r>
-              <a:rPr sz="1300">
+              <a:t>Logro: </a:t>
+            </a:r>
+            <a:r>
+              <a:rPr sz="1200">
                 <a:solidFill>
                   <a:srgbClr val="64748B"/>
                 </a:solidFill>
               </a:rPr>
-              <a:t>en definición.</a:t>
+              <a:t>La IA no solo redacta: actúa, con un control de aprobación («tú apruebas») y «Permitir siempre» revocable, todo auditado.</a:t>
             </a:r>
           </a:p>
           <a:p>
             <a:pPr>
               <a:spcAft>
-                <a:spcPts val="600"/>
+                <a:spcPts val="500"/>
               </a:spcAft>
             </a:pPr>
             <a:r>
-              <a:rPr b="1" sz="1500">
+              <a:rPr b="1" sz="1400">
                 <a:solidFill>
                   <a:srgbClr val="334155"/>
                 </a:solidFill>
               </a:rPr>
-              <a:t>TTS/STT (NaN): </a:t>
-            </a:r>
-            <a:r>
-              <a:rPr sz="1300">
+              <a:t>Caso de uso: </a:t>
+            </a:r>
+            <a:r>
+              <a:rPr sz="1200">
                 <a:solidFill>
                   <a:srgbClr val="64748B"/>
                 </a:solidFill>
               </a:rPr>
-              <a:t>voz y transcripción.</a:t>
+              <a:t>Tras redactar un correo, el usuario pulsa enviar; queda como solicitud pendiente y, al aprobar, se manda desde su cuenta Outlook.</a:t>
             </a:r>
           </a:p>
           <a:p>
             <a:pPr>
               <a:spcAft>
-                <a:spcPts val="600"/>
+                <a:spcPts val="500"/>
               </a:spcAft>
             </a:pPr>
             <a:r>
-              <a:rPr b="1" sz="1500">
+              <a:rPr b="1" sz="1400">
                 <a:solidFill>
                   <a:srgbClr val="334155"/>
                 </a:solidFill>
               </a:rPr>
-              <a:t>SFTP: </a:t>
-            </a:r>
-            <a:r>
-              <a:rPr sz="1300">
+              <a:t>Cómo: </a:t>
+            </a:r>
+            <a:r>
+              <a:rPr sz="1200">
                 <a:solidFill>
                   <a:srgbClr val="64748B"/>
                 </a:solidFill>
               </a:rPr>
-              <a:t>conector legado.</a:t>
+              <a:t>Configura scopes de escritura y reconecta (ver guía de configuración A/B). …</a:t>
             </a:r>
           </a:p>
         </p:txBody>
@@ -3907,14 +3909,6 @@
 <file path=ppt/slides/slide15.xml><?xml version="1.0" encoding="utf-8"?>
 <p:sld xmlns:a="http://schemas.openxmlformats.org/drawingml/2006/main" xmlns:p="http://schemas.openxmlformats.org/presentationml/2006/main" xmlns:r="http://schemas.openxmlformats.org/officeDocument/2006/relationships">
   <p:cSld>
-    <p:bg>
-      <p:bgPr>
-        <a:solidFill>
-          <a:srgbClr val="6D28D9"/>
-        </a:solidFill>
-        <a:effectLst/>
-      </p:bgPr>
-    </p:bg>
     <p:spTree>
       <p:nvGrpSpPr>
         <p:cNvPr id="1" name=""/>
@@ -3930,7 +3924,7 @@
         </p:nvSpPr>
         <p:spPr>
           <a:xfrm>
-            <a:off x="640080" y="2377440"/>
+            <a:off x="640080" y="411480"/>
             <a:ext cx="10972800" cy="1097280"/>
           </a:xfrm>
           <a:prstGeom prst="rect">
@@ -3945,12 +3939,12 @@
           <a:lstStyle/>
           <a:p>
             <a:r>
-              <a:rPr sz="3800" b="1">
-                <a:solidFill>
-                  <a:srgbClr val="FFFFFF"/>
-                </a:solidFill>
-              </a:rPr>
-              <a:t>Gracias</a:t>
+              <a:rPr sz="2600" b="1">
+                <a:solidFill>
+                  <a:srgbClr val="6D28D9"/>
+                </a:solidFill>
+              </a:rPr>
+              <a:t>Automatizaciones y n8n</a:t>
             </a:r>
           </a:p>
         </p:txBody>
@@ -3963,8 +3957,8 @@
         </p:nvSpPr>
         <p:spPr>
           <a:xfrm>
-            <a:off x="640080" y="3566160"/>
-            <a:ext cx="10972800" cy="914400"/>
+            <a:off x="731520" y="1554480"/>
+            <a:ext cx="10698480" cy="4846320"/>
           </a:xfrm>
           <a:prstGeom prst="rect">
             <a:avLst/>
@@ -3972,18 +3966,649 @@
           <a:noFill/>
         </p:spPr>
         <p:txBody>
+          <a:bodyPr wrap="square">
+            <a:spAutoFit/>
+          </a:bodyPr>
+          <a:lstStyle/>
+          <a:p>
+            <a:pPr>
+              <a:spcAft>
+                <a:spcPts val="500"/>
+              </a:spcAft>
+            </a:pPr>
+            <a:r>
+              <a:rPr b="1" sz="1400">
+                <a:solidFill>
+                  <a:srgbClr val="334155"/>
+                </a:solidFill>
+              </a:rPr>
+              <a:t>Logro: </a:t>
+            </a:r>
+            <a:r>
+              <a:rPr sz="1200">
+                <a:solidFill>
+                  <a:srgbClr val="64748B"/>
+                </a:solidFill>
+              </a:rPr>
+              <a:t>Procesos sin intervención: resúmenes diarios, cobranza semanal, alertas de documento sensible, reportes — orquestando los sistemas de la empresa.</a:t>
+            </a:r>
+          </a:p>
+          <a:p>
+            <a:pPr>
+              <a:spcAft>
+                <a:spcPts val="500"/>
+              </a:spcAft>
+            </a:pPr>
+            <a:r>
+              <a:rPr b="1" sz="1400">
+                <a:solidFill>
+                  <a:srgbClr val="334155"/>
+                </a:solidFill>
+              </a:rPr>
+              <a:t>Caso de uso: </a:t>
+            </a:r>
+            <a:r>
+              <a:rPr sz="1200">
+                <a:solidFill>
+                  <a:srgbClr val="64748B"/>
+                </a:solidFill>
+              </a:rPr>
+              <a:t>Cada vez que se sube un documento confidencial, una automatización notifica a seguridad.</a:t>
+            </a:r>
+          </a:p>
+          <a:p>
+            <a:pPr>
+              <a:spcAft>
+                <a:spcPts val="500"/>
+              </a:spcAft>
+            </a:pPr>
+            <a:r>
+              <a:rPr b="1" sz="1400">
+                <a:solidFill>
+                  <a:srgbClr val="334155"/>
+                </a:solidFill>
+              </a:rPr>
+              <a:t>Cómo: </a:t>
+            </a:r>
+            <a:r>
+              <a:rPr sz="1200">
+                <a:solidFill>
+                  <a:srgbClr val="64748B"/>
+                </a:solidFill>
+              </a:rPr>
+              <a:t>Automatizaciones → Nueva (o usa una plantilla). …</a:t>
+            </a:r>
+          </a:p>
+        </p:txBody>
+      </p:sp>
+    </p:spTree>
+  </p:cSld>
+  <p:clrMapOvr>
+    <a:masterClrMapping/>
+  </p:clrMapOvr>
+</p:sld>
+</file>
+
+<file path=ppt/slides/slide16.xml><?xml version="1.0" encoding="utf-8"?>
+<p:sld xmlns:a="http://schemas.openxmlformats.org/drawingml/2006/main" xmlns:p="http://schemas.openxmlformats.org/presentationml/2006/main" xmlns:r="http://schemas.openxmlformats.org/officeDocument/2006/relationships">
+  <p:cSld>
+    <p:spTree>
+      <p:nvGrpSpPr>
+        <p:cNvPr id="1" name=""/>
+        <p:cNvGrpSpPr/>
+        <p:nvPr/>
+      </p:nvGrpSpPr>
+      <p:grpSpPr/>
+      <p:sp>
+        <p:nvSpPr>
+          <p:cNvPr id="2" name="TextBox 1"/>
+          <p:cNvSpPr txBox="1"/>
+          <p:nvPr/>
+        </p:nvSpPr>
+        <p:spPr>
+          <a:xfrm>
+            <a:off x="640080" y="411480"/>
+            <a:ext cx="10972800" cy="1097280"/>
+          </a:xfrm>
+          <a:prstGeom prst="rect">
+            <a:avLst/>
+          </a:prstGeom>
+          <a:noFill/>
+        </p:spPr>
+        <p:txBody>
           <a:bodyPr wrap="none">
             <a:spAutoFit/>
           </a:bodyPr>
           <a:lstStyle/>
           <a:p>
             <a:r>
-              <a:rPr sz="1600">
-                <a:solidFill>
-                  <a:srgbClr val="FFFFFF"/>
-                </a:solidFill>
-              </a:rPr>
-              <a:t>MaestroAI · Documentación 2026</a:t>
+              <a:rPr sz="2600" b="1">
+                <a:solidFill>
+                  <a:srgbClr val="6D28D9"/>
+                </a:solidFill>
+              </a:rPr>
+              <a:t>Conectores, webhooks y API pública</a:t>
+            </a:r>
+          </a:p>
+        </p:txBody>
+      </p:sp>
+      <p:sp>
+        <p:nvSpPr>
+          <p:cNvPr id="3" name="TextBox 2"/>
+          <p:cNvSpPr txBox="1"/>
+          <p:nvPr/>
+        </p:nvSpPr>
+        <p:spPr>
+          <a:xfrm>
+            <a:off x="731520" y="1554480"/>
+            <a:ext cx="10698480" cy="4846320"/>
+          </a:xfrm>
+          <a:prstGeom prst="rect">
+            <a:avLst/>
+          </a:prstGeom>
+          <a:noFill/>
+        </p:spPr>
+        <p:txBody>
+          <a:bodyPr wrap="square">
+            <a:spAutoFit/>
+          </a:bodyPr>
+          <a:lstStyle/>
+          <a:p>
+            <a:pPr>
+              <a:spcAft>
+                <a:spcPts val="500"/>
+              </a:spcAft>
+            </a:pPr>
+            <a:r>
+              <a:rPr b="1" sz="1400">
+                <a:solidFill>
+                  <a:srgbClr val="334155"/>
+                </a:solidFill>
+              </a:rPr>
+              <a:t>Logro: </a:t>
+            </a:r>
+            <a:r>
+              <a:rPr sz="1200">
+                <a:solidFill>
+                  <a:srgbClr val="64748B"/>
+                </a:solidFill>
+              </a:rPr>
+              <a:t>Integración bidireccional gobernada con el ecosistema de la empresa, sin exponer secretos.</a:t>
+            </a:r>
+          </a:p>
+          <a:p>
+            <a:pPr>
+              <a:spcAft>
+                <a:spcPts val="500"/>
+              </a:spcAft>
+            </a:pPr>
+            <a:r>
+              <a:rPr b="1" sz="1400">
+                <a:solidFill>
+                  <a:srgbClr val="334155"/>
+                </a:solidFill>
+              </a:rPr>
+              <a:t>Caso de uso: </a:t>
+            </a:r>
+            <a:r>
+              <a:rPr sz="1200">
+                <a:solidFill>
+                  <a:srgbClr val="64748B"/>
+                </a:solidFill>
+              </a:rPr>
+              <a:t>Un lead capturado en la plataforma se envía a HubSpot vía conector; un sistema externo notifica eventos por webhook firmado.</a:t>
+            </a:r>
+          </a:p>
+          <a:p>
+            <a:pPr>
+              <a:spcAft>
+                <a:spcPts val="500"/>
+              </a:spcAft>
+            </a:pPr>
+            <a:r>
+              <a:rPr b="1" sz="1400">
+                <a:solidFill>
+                  <a:srgbClr val="334155"/>
+                </a:solidFill>
+              </a:rPr>
+              <a:t>Cómo: </a:t>
+            </a:r>
+            <a:r>
+              <a:rPr sz="1200">
+                <a:solidFill>
+                  <a:srgbClr val="64748B"/>
+                </a:solidFill>
+              </a:rPr>
+              <a:t>Integraciones → Conectores: plantilla, endpoint y token (cifrado); Probar. …</a:t>
+            </a:r>
+          </a:p>
+        </p:txBody>
+      </p:sp>
+    </p:spTree>
+  </p:cSld>
+  <p:clrMapOvr>
+    <a:masterClrMapping/>
+  </p:clrMapOvr>
+</p:sld>
+</file>
+
+<file path=ppt/slides/slide17.xml><?xml version="1.0" encoding="utf-8"?>
+<p:sld xmlns:a="http://schemas.openxmlformats.org/drawingml/2006/main" xmlns:p="http://schemas.openxmlformats.org/presentationml/2006/main" xmlns:r="http://schemas.openxmlformats.org/officeDocument/2006/relationships">
+  <p:cSld>
+    <p:spTree>
+      <p:nvGrpSpPr>
+        <p:cNvPr id="1" name=""/>
+        <p:cNvGrpSpPr/>
+        <p:nvPr/>
+      </p:nvGrpSpPr>
+      <p:grpSpPr/>
+      <p:sp>
+        <p:nvSpPr>
+          <p:cNvPr id="2" name="TextBox 1"/>
+          <p:cNvSpPr txBox="1"/>
+          <p:nvPr/>
+        </p:nvSpPr>
+        <p:spPr>
+          <a:xfrm>
+            <a:off x="640080" y="411480"/>
+            <a:ext cx="10972800" cy="1097280"/>
+          </a:xfrm>
+          <a:prstGeom prst="rect">
+            <a:avLst/>
+          </a:prstGeom>
+          <a:noFill/>
+        </p:spPr>
+        <p:txBody>
+          <a:bodyPr wrap="none">
+            <a:spAutoFit/>
+          </a:bodyPr>
+          <a:lstStyle/>
+          <a:p>
+            <a:r>
+              <a:rPr sz="2600" b="1">
+                <a:solidFill>
+                  <a:srgbClr val="6D28D9"/>
+                </a:solidFill>
+              </a:rPr>
+              <a:t>Fuentes de datos legadas (BD de solo lectura / CSV)</a:t>
+            </a:r>
+          </a:p>
+        </p:txBody>
+      </p:sp>
+      <p:sp>
+        <p:nvSpPr>
+          <p:cNvPr id="3" name="TextBox 2"/>
+          <p:cNvSpPr txBox="1"/>
+          <p:nvPr/>
+        </p:nvSpPr>
+        <p:spPr>
+          <a:xfrm>
+            <a:off x="731520" y="1554480"/>
+            <a:ext cx="10698480" cy="4846320"/>
+          </a:xfrm>
+          <a:prstGeom prst="rect">
+            <a:avLst/>
+          </a:prstGeom>
+          <a:noFill/>
+        </p:spPr>
+        <p:txBody>
+          <a:bodyPr wrap="square">
+            <a:spAutoFit/>
+          </a:bodyPr>
+          <a:lstStyle/>
+          <a:p>
+            <a:pPr>
+              <a:spcAft>
+                <a:spcPts val="500"/>
+              </a:spcAft>
+            </a:pPr>
+            <a:r>
+              <a:rPr b="1" sz="1400">
+                <a:solidFill>
+                  <a:srgbClr val="334155"/>
+                </a:solidFill>
+              </a:rPr>
+              <a:t>Logro: </a:t>
+            </a:r>
+            <a:r>
+              <a:rPr sz="1200">
+                <a:solidFill>
+                  <a:srgbClr val="64748B"/>
+                </a:solidFill>
+              </a:rPr>
+              <a:t>Trae el conocimiento de sistemas sin API a la IA gobernada, sin exponer escritura ni romper el sistema legado.</a:t>
+            </a:r>
+          </a:p>
+          <a:p>
+            <a:pPr>
+              <a:spcAft>
+                <a:spcPts val="500"/>
+              </a:spcAft>
+            </a:pPr>
+            <a:r>
+              <a:rPr b="1" sz="1400">
+                <a:solidFill>
+                  <a:srgbClr val="334155"/>
+                </a:solidFill>
+              </a:rPr>
+              <a:t>Caso de uso: </a:t>
+            </a:r>
+            <a:r>
+              <a:rPr sz="1200">
+                <a:solidFill>
+                  <a:srgbClr val="64748B"/>
+                </a:solidFill>
+              </a:rPr>
+              <a:t>Un ERP antiguo exporta clientes en CSV; se importan al RAG y el chat ya responde sobre ellos.</a:t>
+            </a:r>
+          </a:p>
+          <a:p>
+            <a:pPr>
+              <a:spcAft>
+                <a:spcPts val="500"/>
+              </a:spcAft>
+            </a:pPr>
+            <a:r>
+              <a:rPr b="1" sz="1400">
+                <a:solidFill>
+                  <a:srgbClr val="334155"/>
+                </a:solidFill>
+              </a:rPr>
+              <a:t>Cómo: </a:t>
+            </a:r>
+            <a:r>
+              <a:rPr sz="1200">
+                <a:solidFill>
+                  <a:srgbClr val="64748B"/>
+                </a:solidFill>
+              </a:rPr>
+              <a:t>Integraciones → Fuentes de datos: DSN + SELECT → Probar → Importar. …</a:t>
+            </a:r>
+          </a:p>
+        </p:txBody>
+      </p:sp>
+    </p:spTree>
+  </p:cSld>
+  <p:clrMapOvr>
+    <a:masterClrMapping/>
+  </p:clrMapOvr>
+</p:sld>
+</file>
+
+<file path=ppt/slides/slide18.xml><?xml version="1.0" encoding="utf-8"?>
+<p:sld xmlns:a="http://schemas.openxmlformats.org/drawingml/2006/main" xmlns:p="http://schemas.openxmlformats.org/presentationml/2006/main" xmlns:r="http://schemas.openxmlformats.org/officeDocument/2006/relationships">
+  <p:cSld>
+    <p:spTree>
+      <p:nvGrpSpPr>
+        <p:cNvPr id="1" name=""/>
+        <p:cNvGrpSpPr/>
+        <p:nvPr/>
+      </p:nvGrpSpPr>
+      <p:grpSpPr/>
+      <p:sp>
+        <p:nvSpPr>
+          <p:cNvPr id="2" name="TextBox 1"/>
+          <p:cNvSpPr txBox="1"/>
+          <p:nvPr/>
+        </p:nvSpPr>
+        <p:spPr>
+          <a:xfrm>
+            <a:off x="640080" y="411480"/>
+            <a:ext cx="10972800" cy="1097280"/>
+          </a:xfrm>
+          <a:prstGeom prst="rect">
+            <a:avLst/>
+          </a:prstGeom>
+          <a:noFill/>
+        </p:spPr>
+        <p:txBody>
+          <a:bodyPr wrap="none">
+            <a:spAutoFit/>
+          </a:bodyPr>
+          <a:lstStyle/>
+          <a:p>
+            <a:r>
+              <a:rPr sz="2600" b="1">
+                <a:solidFill>
+                  <a:srgbClr val="6D28D9"/>
+                </a:solidFill>
+              </a:rPr>
+              <a:t>Tableros, Trámites y App Studio</a:t>
+            </a:r>
+          </a:p>
+        </p:txBody>
+      </p:sp>
+      <p:sp>
+        <p:nvSpPr>
+          <p:cNvPr id="3" name="TextBox 2"/>
+          <p:cNvSpPr txBox="1"/>
+          <p:nvPr/>
+        </p:nvSpPr>
+        <p:spPr>
+          <a:xfrm>
+            <a:off x="731520" y="1554480"/>
+            <a:ext cx="10698480" cy="4846320"/>
+          </a:xfrm>
+          <a:prstGeom prst="rect">
+            <a:avLst/>
+          </a:prstGeom>
+          <a:noFill/>
+        </p:spPr>
+        <p:txBody>
+          <a:bodyPr wrap="square">
+            <a:spAutoFit/>
+          </a:bodyPr>
+          <a:lstStyle/>
+          <a:p>
+            <a:pPr>
+              <a:spcAft>
+                <a:spcPts val="500"/>
+              </a:spcAft>
+            </a:pPr>
+            <a:r>
+              <a:rPr b="1" sz="1400">
+                <a:solidFill>
+                  <a:srgbClr val="334155"/>
+                </a:solidFill>
+              </a:rPr>
+              <a:t>Logro: </a:t>
+            </a:r>
+            <a:r>
+              <a:rPr sz="1200">
+                <a:solidFill>
+                  <a:srgbClr val="64748B"/>
+                </a:solidFill>
+              </a:rPr>
+              <a:t>Medición y contexto público/privado curado, y la posibilidad de publicar mini-aplicaciones.</a:t>
+            </a:r>
+          </a:p>
+          <a:p>
+            <a:pPr>
+              <a:spcAft>
+                <a:spcPts val="500"/>
+              </a:spcAft>
+            </a:pPr>
+            <a:r>
+              <a:rPr b="1" sz="1400">
+                <a:solidFill>
+                  <a:srgbClr val="334155"/>
+                </a:solidFill>
+              </a:rPr>
+              <a:t>Caso de uso: </a:t>
+            </a:r>
+            <a:r>
+              <a:rPr sz="1200">
+                <a:solidFill>
+                  <a:srgbClr val="64748B"/>
+                </a:solidFill>
+              </a:rPr>
+              <a:t>Un gerente arma un tablero de «costo por ruta de modelo» y casos por receta; convierte un trámite estatal en una propuesta de caso de uso.</a:t>
+            </a:r>
+          </a:p>
+          <a:p>
+            <a:pPr>
+              <a:spcAft>
+                <a:spcPts val="500"/>
+              </a:spcAft>
+            </a:pPr>
+            <a:r>
+              <a:rPr b="1" sz="1400">
+                <a:solidFill>
+                  <a:srgbClr val="334155"/>
+                </a:solidFill>
+              </a:rPr>
+              <a:t>Cómo: </a:t>
+            </a:r>
+            <a:r>
+              <a:rPr sz="1200">
+                <a:solidFill>
+                  <a:srgbClr val="64748B"/>
+                </a:solidFill>
+              </a:rPr>
+              <a:t>Tableros → describe lo que quieres medir y agrega widgets. …</a:t>
+            </a:r>
+          </a:p>
+        </p:txBody>
+      </p:sp>
+    </p:spTree>
+  </p:cSld>
+  <p:clrMapOvr>
+    <a:masterClrMapping/>
+  </p:clrMapOvr>
+</p:sld>
+</file>
+
+<file path=ppt/slides/slide19.xml><?xml version="1.0" encoding="utf-8"?>
+<p:sld xmlns:a="http://schemas.openxmlformats.org/drawingml/2006/main" xmlns:p="http://schemas.openxmlformats.org/presentationml/2006/main" xmlns:r="http://schemas.openxmlformats.org/officeDocument/2006/relationships">
+  <p:cSld>
+    <p:spTree>
+      <p:nvGrpSpPr>
+        <p:cNvPr id="1" name=""/>
+        <p:cNvGrpSpPr/>
+        <p:nvPr/>
+      </p:nvGrpSpPr>
+      <p:grpSpPr/>
+      <p:sp>
+        <p:nvSpPr>
+          <p:cNvPr id="2" name="TextBox 1"/>
+          <p:cNvSpPr txBox="1"/>
+          <p:nvPr/>
+        </p:nvSpPr>
+        <p:spPr>
+          <a:xfrm>
+            <a:off x="640080" y="411480"/>
+            <a:ext cx="10972800" cy="1097280"/>
+          </a:xfrm>
+          <a:prstGeom prst="rect">
+            <a:avLst/>
+          </a:prstGeom>
+          <a:noFill/>
+        </p:spPr>
+        <p:txBody>
+          <a:bodyPr wrap="none">
+            <a:spAutoFit/>
+          </a:bodyPr>
+          <a:lstStyle/>
+          <a:p>
+            <a:r>
+              <a:rPr sz="2600" b="1">
+                <a:solidFill>
+                  <a:srgbClr val="6D28D9"/>
+                </a:solidFill>
+              </a:rPr>
+              <a:t>Auditoría, gobernanza y multi-tenant</a:t>
+            </a:r>
+          </a:p>
+        </p:txBody>
+      </p:sp>
+      <p:sp>
+        <p:nvSpPr>
+          <p:cNvPr id="3" name="TextBox 2"/>
+          <p:cNvSpPr txBox="1"/>
+          <p:nvPr/>
+        </p:nvSpPr>
+        <p:spPr>
+          <a:xfrm>
+            <a:off x="731520" y="1554480"/>
+            <a:ext cx="10698480" cy="4846320"/>
+          </a:xfrm>
+          <a:prstGeom prst="rect">
+            <a:avLst/>
+          </a:prstGeom>
+          <a:noFill/>
+        </p:spPr>
+        <p:txBody>
+          <a:bodyPr wrap="square">
+            <a:spAutoFit/>
+          </a:bodyPr>
+          <a:lstStyle/>
+          <a:p>
+            <a:pPr>
+              <a:spcAft>
+                <a:spcPts val="500"/>
+              </a:spcAft>
+            </a:pPr>
+            <a:r>
+              <a:rPr b="1" sz="1400">
+                <a:solidFill>
+                  <a:srgbClr val="334155"/>
+                </a:solidFill>
+              </a:rPr>
+              <a:t>Logro: </a:t>
+            </a:r>
+            <a:r>
+              <a:rPr sz="1200">
+                <a:solidFill>
+                  <a:srgbClr val="64748B"/>
+                </a:solidFill>
+              </a:rPr>
+              <a:t>Evidencia y control para cumplimiento y seguridad; cada empresa aislada; cada usuario ve lo suyo.</a:t>
+            </a:r>
+          </a:p>
+          <a:p>
+            <a:pPr>
+              <a:spcAft>
+                <a:spcPts val="500"/>
+              </a:spcAft>
+            </a:pPr>
+            <a:r>
+              <a:rPr b="1" sz="1400">
+                <a:solidFill>
+                  <a:srgbClr val="334155"/>
+                </a:solidFill>
+              </a:rPr>
+              <a:t>Caso de uso: </a:t>
+            </a:r>
+            <a:r>
+              <a:rPr sz="1200">
+                <a:solidFill>
+                  <a:srgbClr val="64748B"/>
+                </a:solidFill>
+              </a:rPr>
+              <a:t>Compliance revisa en Auditoría todas las salidas externas del mes y las exporta a su SIEM.</a:t>
+            </a:r>
+          </a:p>
+          <a:p>
+            <a:pPr>
+              <a:spcAft>
+                <a:spcPts val="500"/>
+              </a:spcAft>
+            </a:pPr>
+            <a:r>
+              <a:rPr b="1" sz="1400">
+                <a:solidFill>
+                  <a:srgbClr val="334155"/>
+                </a:solidFill>
+              </a:rPr>
+              <a:t>Cómo: </a:t>
+            </a:r>
+            <a:r>
+              <a:rPr sz="1200">
+                <a:solidFill>
+                  <a:srgbClr val="64748B"/>
+                </a:solidFill>
+              </a:rPr>
+              <a:t>Auditoría → filtra por tipo, riesgo, ruta o usuario; abre el detalle. …</a:t>
             </a:r>
           </a:p>
         </p:txBody>
@@ -4029,12 +4654,12 @@
           <a:lstStyle/>
           <a:p>
             <a:r>
-              <a:rPr sz="2800" b="1">
+              <a:rPr sz="2600" b="1">
                 <a:solidFill>
                   <a:srgbClr val="6D28D9"/>
                 </a:solidFill>
               </a:rPr>
-              <a:t>El problema</a:t>
+              <a:t>Propuesta de valor</a:t>
             </a:r>
           </a:p>
         </p:txBody>
@@ -4047,8 +4672,8 @@
         </p:nvSpPr>
         <p:spPr>
           <a:xfrm>
-            <a:off x="640080" y="1325880"/>
-            <a:ext cx="10972800" cy="914400"/>
+            <a:off x="731520" y="1554480"/>
+            <a:ext cx="10698480" cy="4846320"/>
           </a:xfrm>
           <a:prstGeom prst="rect">
             <a:avLst/>
@@ -4056,32 +4681,132 @@
           <a:noFill/>
         </p:spPr>
         <p:txBody>
-          <a:bodyPr wrap="none">
+          <a:bodyPr wrap="square">
             <a:spAutoFit/>
           </a:bodyPr>
           <a:lstStyle/>
           <a:p>
-            <a:r>
-              <a:rPr sz="1600">
+            <a:pPr>
+              <a:spcAft>
+                <a:spcPts val="500"/>
+              </a:spcAft>
+            </a:pPr>
+            <a:r>
+              <a:rPr b="1" sz="1400">
+                <a:solidFill>
+                  <a:srgbClr val="334155"/>
+                </a:solidFill>
+              </a:rPr>
+              <a:t>Capa privada y gobernada: </a:t>
+            </a:r>
+            <a:r>
+              <a:rPr sz="1200">
                 <a:solidFill>
                   <a:srgbClr val="64748B"/>
                 </a:solidFill>
               </a:rPr>
-              <a:t>Por qué MaestroAI y no «otro ChatGPT».</a:t>
-            </a:r>
-          </a:p>
-        </p:txBody>
-      </p:sp>
-      <p:sp>
-        <p:nvSpPr>
-          <p:cNvPr id="4" name="TextBox 3"/>
+              <a:t>sobre cualquier modelo.</a:t>
+            </a:r>
+          </a:p>
+          <a:p>
+            <a:pPr>
+              <a:spcAft>
+                <a:spcPts val="500"/>
+              </a:spcAft>
+            </a:pPr>
+            <a:r>
+              <a:rPr b="1" sz="1400">
+                <a:solidFill>
+                  <a:srgbClr val="334155"/>
+                </a:solidFill>
+              </a:rPr>
+              <a:t>Enrutador de Privacidad: </a:t>
+            </a:r>
+            <a:r>
+              <a:rPr sz="1200">
+                <a:solidFill>
+                  <a:srgbClr val="64748B"/>
+                </a:solidFill>
+              </a:rPr>
+              <a:t>clasifica, redacta y decide por cada dato.</a:t>
+            </a:r>
+          </a:p>
+          <a:p>
+            <a:pPr>
+              <a:spcAft>
+                <a:spcPts val="500"/>
+              </a:spcAft>
+            </a:pPr>
+            <a:r>
+              <a:rPr b="1" sz="1400">
+                <a:solidFill>
+                  <a:srgbClr val="334155"/>
+                </a:solidFill>
+              </a:rPr>
+              <a:t>RAG por área + rerank: </a:t>
+            </a:r>
+            <a:r>
+              <a:rPr sz="1200">
+                <a:solidFill>
+                  <a:srgbClr val="64748B"/>
+                </a:solidFill>
+              </a:rPr>
+              <a:t>respuestas con fuentes y permisos.</a:t>
+            </a:r>
+          </a:p>
+          <a:p>
+            <a:pPr>
+              <a:spcAft>
+                <a:spcPts val="500"/>
+              </a:spcAft>
+            </a:pPr>
+            <a:r>
+              <a:rPr b="1" sz="1400">
+                <a:solidFill>
+                  <a:srgbClr val="334155"/>
+                </a:solidFill>
+              </a:rPr>
+              <a:t>Actúa, no solo redacta: </a:t>
+            </a:r>
+            <a:r>
+              <a:rPr sz="1200">
+                <a:solidFill>
+                  <a:srgbClr val="64748B"/>
+                </a:solidFill>
+              </a:rPr>
+              <a:t>toolkit con aprobación humana.</a:t>
+            </a:r>
+          </a:p>
+        </p:txBody>
+      </p:sp>
+    </p:spTree>
+  </p:cSld>
+  <p:clrMapOvr>
+    <a:masterClrMapping/>
+  </p:clrMapOvr>
+</p:sld>
+</file>
+
+<file path=ppt/slides/slide20.xml><?xml version="1.0" encoding="utf-8"?>
+<p:sld xmlns:a="http://schemas.openxmlformats.org/drawingml/2006/main" xmlns:p="http://schemas.openxmlformats.org/presentationml/2006/main" xmlns:r="http://schemas.openxmlformats.org/officeDocument/2006/relationships">
+  <p:cSld>
+    <p:spTree>
+      <p:nvGrpSpPr>
+        <p:cNvPr id="1" name=""/>
+        <p:cNvGrpSpPr/>
+        <p:nvPr/>
+      </p:nvGrpSpPr>
+      <p:grpSpPr/>
+      <p:sp>
+        <p:nvSpPr>
+          <p:cNvPr id="2" name="TextBox 1"/>
           <p:cNvSpPr txBox="1"/>
           <p:nvPr/>
         </p:nvSpPr>
         <p:spPr>
           <a:xfrm>
-            <a:off x="731520" y="1554480"/>
-            <a:ext cx="10698480" cy="4846320"/>
+            <a:off x="640080" y="411480"/>
+            <a:ext cx="10972800" cy="1097280"/>
           </a:xfrm>
           <a:prstGeom prst="rect">
             <a:avLst/>
@@ -4089,6 +4814,72 @@
           <a:noFill/>
         </p:spPr>
         <p:txBody>
+          <a:bodyPr wrap="none">
+            <a:spAutoFit/>
+          </a:bodyPr>
+          <a:lstStyle/>
+          <a:p>
+            <a:r>
+              <a:rPr sz="2600" b="1">
+                <a:solidFill>
+                  <a:srgbClr val="6D28D9"/>
+                </a:solidFill>
+              </a:rPr>
+              <a:t>Configuración — lo que se conecta</a:t>
+            </a:r>
+          </a:p>
+        </p:txBody>
+      </p:sp>
+      <p:sp>
+        <p:nvSpPr>
+          <p:cNvPr id="3" name="TextBox 2"/>
+          <p:cNvSpPr txBox="1"/>
+          <p:nvPr/>
+        </p:nvSpPr>
+        <p:spPr>
+          <a:xfrm>
+            <a:off x="640080" y="1280160"/>
+            <a:ext cx="10972800" cy="914400"/>
+          </a:xfrm>
+          <a:prstGeom prst="rect">
+            <a:avLst/>
+          </a:prstGeom>
+          <a:noFill/>
+        </p:spPr>
+        <p:txBody>
+          <a:bodyPr wrap="none">
+            <a:spAutoFit/>
+          </a:bodyPr>
+          <a:lstStyle/>
+          <a:p>
+            <a:r>
+              <a:rPr sz="1500">
+                <a:solidFill>
+                  <a:srgbClr val="64748B"/>
+                </a:solidFill>
+              </a:rPr>
+              <a:t>Guías paso a paso en la sección 6 del documento.</a:t>
+            </a:r>
+          </a:p>
+        </p:txBody>
+      </p:sp>
+      <p:sp>
+        <p:nvSpPr>
+          <p:cNvPr id="4" name="TextBox 3"/>
+          <p:cNvSpPr txBox="1"/>
+          <p:nvPr/>
+        </p:nvSpPr>
+        <p:spPr>
+          <a:xfrm>
+            <a:off x="731520" y="1554480"/>
+            <a:ext cx="10698480" cy="4846320"/>
+          </a:xfrm>
+          <a:prstGeom prst="rect">
+            <a:avLst/>
+          </a:prstGeom>
+          <a:noFill/>
+        </p:spPr>
+        <p:txBody>
           <a:bodyPr wrap="square">
             <a:spAutoFit/>
           </a:bodyPr>
@@ -4096,46 +4887,319 @@
           <a:p>
             <a:pPr>
               <a:spcAft>
-                <a:spcPts val="600"/>
+                <a:spcPts val="500"/>
               </a:spcAft>
             </a:pPr>
             <a:r>
-              <a:rPr sz="1500">
+              <a:rPr b="1" sz="1400">
                 <a:solidFill>
                   <a:srgbClr val="334155"/>
                 </a:solidFill>
               </a:rPr>
-              <a:t>• Las empresas quieren IA pero no pueden exponer datos sensibles ni perder control.</a:t>
+              <a:t>Correo: </a:t>
+            </a:r>
+            <a:r>
+              <a:rPr sz="1200">
+                <a:solidFill>
+                  <a:srgbClr val="64748B"/>
+                </a:solidFill>
+              </a:rPr>
+              <a:t>OAuth Microsoft/Google + IMAP.</a:t>
             </a:r>
           </a:p>
           <a:p>
             <a:pPr>
               <a:spcAft>
-                <a:spcPts val="600"/>
+                <a:spcPts val="500"/>
               </a:spcAft>
             </a:pPr>
             <a:r>
-              <a:rPr sz="1500">
+              <a:rPr b="1" sz="1400">
                 <a:solidFill>
                   <a:srgbClr val="334155"/>
                 </a:solidFill>
               </a:rPr>
-              <a:t>• Los asistentes genéricos no clasifican, no auditan y no respetan políticas por área.</a:t>
+              <a:t>Modelos: </a:t>
+            </a:r>
+            <a:r>
+              <a:rPr sz="1200">
+                <a:solidFill>
+                  <a:srgbClr val="64748B"/>
+                </a:solidFill>
+              </a:rPr>
+              <a:t>NaN (open), premium, Ollama (local).</a:t>
             </a:r>
           </a:p>
           <a:p>
             <a:pPr>
               <a:spcAft>
-                <a:spcPts val="600"/>
+                <a:spcPts val="500"/>
               </a:spcAft>
             </a:pPr>
             <a:r>
+              <a:rPr b="1" sz="1400">
+                <a:solidFill>
+                  <a:srgbClr val="334155"/>
+                </a:solidFill>
+              </a:rPr>
+              <a:t>Automatización: </a:t>
+            </a:r>
+            <a:r>
+              <a:rPr sz="1200">
+                <a:solidFill>
+                  <a:srgbClr val="64748B"/>
+                </a:solidFill>
+              </a:rPr>
+              <a:t>n8n + conectores + webhooks.</a:t>
+            </a:r>
+          </a:p>
+          <a:p>
+            <a:pPr>
+              <a:spcAft>
+                <a:spcPts val="500"/>
+              </a:spcAft>
+            </a:pPr>
+            <a:r>
+              <a:rPr b="1" sz="1400">
+                <a:solidFill>
+                  <a:srgbClr val="334155"/>
+                </a:solidFill>
+              </a:rPr>
+              <a:t>Gobierno: </a:t>
+            </a:r>
+            <a:r>
+              <a:rPr sz="1200">
+                <a:solidFill>
+                  <a:srgbClr val="64748B"/>
+                </a:solidFill>
+              </a:rPr>
+              <a:t>rerank, eficiencia, proteger ramas.</a:t>
+            </a:r>
+          </a:p>
+        </p:txBody>
+      </p:sp>
+    </p:spTree>
+  </p:cSld>
+  <p:clrMapOvr>
+    <a:masterClrMapping/>
+  </p:clrMapOvr>
+</p:sld>
+</file>
+
+<file path=ppt/slides/slide21.xml><?xml version="1.0" encoding="utf-8"?>
+<p:sld xmlns:a="http://schemas.openxmlformats.org/drawingml/2006/main" xmlns:p="http://schemas.openxmlformats.org/presentationml/2006/main" xmlns:r="http://schemas.openxmlformats.org/officeDocument/2006/relationships">
+  <p:cSld>
+    <p:spTree>
+      <p:nvGrpSpPr>
+        <p:cNvPr id="1" name=""/>
+        <p:cNvGrpSpPr/>
+        <p:nvPr/>
+      </p:nvGrpSpPr>
+      <p:grpSpPr/>
+      <p:sp>
+        <p:nvSpPr>
+          <p:cNvPr id="2" name="TextBox 1"/>
+          <p:cNvSpPr txBox="1"/>
+          <p:nvPr/>
+        </p:nvSpPr>
+        <p:spPr>
+          <a:xfrm>
+            <a:off x="640080" y="411480"/>
+            <a:ext cx="10972800" cy="1097280"/>
+          </a:xfrm>
+          <a:prstGeom prst="rect">
+            <a:avLst/>
+          </a:prstGeom>
+          <a:noFill/>
+        </p:spPr>
+        <p:txBody>
+          <a:bodyPr wrap="none">
+            <a:spAutoFit/>
+          </a:bodyPr>
+          <a:lstStyle/>
+          <a:p>
+            <a:r>
+              <a:rPr sz="2600" b="1">
+                <a:solidFill>
+                  <a:srgbClr val="6D28D9"/>
+                </a:solidFill>
+              </a:rPr>
+              <a:t>Seguridad y cumplimiento</a:t>
+            </a:r>
+          </a:p>
+        </p:txBody>
+      </p:sp>
+      <p:sp>
+        <p:nvSpPr>
+          <p:cNvPr id="3" name="TextBox 2"/>
+          <p:cNvSpPr txBox="1"/>
+          <p:nvPr/>
+        </p:nvSpPr>
+        <p:spPr>
+          <a:xfrm>
+            <a:off x="731520" y="1554480"/>
+            <a:ext cx="10698480" cy="4846320"/>
+          </a:xfrm>
+          <a:prstGeom prst="rect">
+            <a:avLst/>
+          </a:prstGeom>
+          <a:noFill/>
+        </p:spPr>
+        <p:txBody>
+          <a:bodyPr wrap="square">
+            <a:spAutoFit/>
+          </a:bodyPr>
+          <a:lstStyle/>
+          <a:p>
+            <a:pPr>
+              <a:spcAft>
+                <a:spcPts val="500"/>
+              </a:spcAft>
+            </a:pPr>
+            <a:r>
+              <a:rPr sz="1400">
+                <a:solidFill>
+                  <a:srgbClr val="334155"/>
+                </a:solidFill>
+              </a:rPr>
+              <a:t>• Cifrado AES-256-GCM por tenant.</a:t>
+            </a:r>
+          </a:p>
+          <a:p>
+            <a:pPr>
+              <a:spcAft>
+                <a:spcPts val="500"/>
+              </a:spcAft>
+            </a:pPr>
+            <a:r>
+              <a:rPr sz="1400">
+                <a:solidFill>
+                  <a:srgbClr val="334155"/>
+                </a:solidFill>
+              </a:rPr>
+              <a:t>• Redacción de PII + minimización.</a:t>
+            </a:r>
+          </a:p>
+          <a:p>
+            <a:pPr>
+              <a:spcAft>
+                <a:spcPts val="500"/>
+              </a:spcAft>
+            </a:pPr>
+            <a:r>
+              <a:rPr sz="1400">
+                <a:solidFill>
+                  <a:srgbClr val="334155"/>
+                </a:solidFill>
+              </a:rPr>
+              <a:t>• Auditoría total + export SIEM.</a:t>
+            </a:r>
+          </a:p>
+          <a:p>
+            <a:pPr>
+              <a:spcAft>
+                <a:spcPts val="500"/>
+              </a:spcAft>
+            </a:pPr>
+            <a:r>
+              <a:rPr sz="1400">
+                <a:solidFill>
+                  <a:srgbClr val="334155"/>
+                </a:solidFill>
+              </a:rPr>
+              <a:t>• LFPDPPP · OWASP LLM 2025 · NIST AI RMF.</a:t>
+            </a:r>
+          </a:p>
+        </p:txBody>
+      </p:sp>
+    </p:spTree>
+  </p:cSld>
+  <p:clrMapOvr>
+    <a:masterClrMapping/>
+  </p:clrMapOvr>
+</p:sld>
+</file>
+
+<file path=ppt/slides/slide22.xml><?xml version="1.0" encoding="utf-8"?>
+<p:sld xmlns:a="http://schemas.openxmlformats.org/drawingml/2006/main" xmlns:p="http://schemas.openxmlformats.org/presentationml/2006/main" xmlns:r="http://schemas.openxmlformats.org/officeDocument/2006/relationships">
+  <p:cSld>
+    <p:bg>
+      <p:bgPr>
+        <a:solidFill>
+          <a:srgbClr val="6D28D9"/>
+        </a:solidFill>
+        <a:effectLst/>
+      </p:bgPr>
+    </p:bg>
+    <p:spTree>
+      <p:nvGrpSpPr>
+        <p:cNvPr id="1" name=""/>
+        <p:cNvGrpSpPr/>
+        <p:nvPr/>
+      </p:nvGrpSpPr>
+      <p:grpSpPr/>
+      <p:sp>
+        <p:nvSpPr>
+          <p:cNvPr id="2" name="TextBox 1"/>
+          <p:cNvSpPr txBox="1"/>
+          <p:nvPr/>
+        </p:nvSpPr>
+        <p:spPr>
+          <a:xfrm>
+            <a:off x="640080" y="2377440"/>
+            <a:ext cx="10972800" cy="1097280"/>
+          </a:xfrm>
+          <a:prstGeom prst="rect">
+            <a:avLst/>
+          </a:prstGeom>
+          <a:noFill/>
+        </p:spPr>
+        <p:txBody>
+          <a:bodyPr wrap="none">
+            <a:spAutoFit/>
+          </a:bodyPr>
+          <a:lstStyle/>
+          <a:p>
+            <a:r>
+              <a:rPr sz="3600" b="1">
+                <a:solidFill>
+                  <a:srgbClr val="FFFFFF"/>
+                </a:solidFill>
+              </a:rPr>
+              <a:t>Gracias</a:t>
+            </a:r>
+          </a:p>
+        </p:txBody>
+      </p:sp>
+      <p:sp>
+        <p:nvSpPr>
+          <p:cNvPr id="3" name="TextBox 2"/>
+          <p:cNvSpPr txBox="1"/>
+          <p:nvPr/>
+        </p:nvSpPr>
+        <p:spPr>
+          <a:xfrm>
+            <a:off x="640080" y="3566160"/>
+            <a:ext cx="10972800" cy="914400"/>
+          </a:xfrm>
+          <a:prstGeom prst="rect">
+            <a:avLst/>
+          </a:prstGeom>
+          <a:noFill/>
+        </p:spPr>
+        <p:txBody>
+          <a:bodyPr wrap="none">
+            <a:spAutoFit/>
+          </a:bodyPr>
+          <a:lstStyle/>
+          <a:p>
+            <a:r>
               <a:rPr sz="1500">
                 <a:solidFill>
-                  <a:srgbClr val="334155"/>
-                </a:solidFill>
-              </a:rPr>
-              <a:t>• Falta trazabilidad, gobierno de costo y soberanía de datos (LFPDPPP).</a:t>
+                  <a:srgbClr val="FFFFFF"/>
+                </a:solidFill>
+              </a:rPr>
+              <a:t>MaestroAI · Documentación 2026</a:t>
             </a:r>
           </a:p>
         </p:txBody>
@@ -4181,12 +5245,12 @@
           <a:lstStyle/>
           <a:p>
             <a:r>
-              <a:rPr sz="2800" b="1">
+              <a:rPr sz="2600" b="1">
                 <a:solidFill>
                   <a:srgbClr val="6D28D9"/>
                 </a:solidFill>
               </a:rPr>
-              <a:t>La propuesta</a:t>
+              <a:t>Cómo decide la ruta</a:t>
             </a:r>
           </a:p>
         </p:txBody>
@@ -4199,8 +5263,8 @@
         </p:nvSpPr>
         <p:spPr>
           <a:xfrm>
-            <a:off x="731520" y="1554480"/>
-            <a:ext cx="10698480" cy="4846320"/>
+            <a:off x="640080" y="1280160"/>
+            <a:ext cx="10972800" cy="914400"/>
           </a:xfrm>
           <a:prstGeom prst="rect">
             <a:avLst/>
@@ -4208,6 +5272,39 @@
           <a:noFill/>
         </p:spPr>
         <p:txBody>
+          <a:bodyPr wrap="none">
+            <a:spAutoFit/>
+          </a:bodyPr>
+          <a:lstStyle/>
+          <a:p>
+            <a:r>
+              <a:rPr sz="1500">
+                <a:solidFill>
+                  <a:srgbClr val="64748B"/>
+                </a:solidFill>
+              </a:rPr>
+              <a:t>El usuario nunca elige el modelo.</a:t>
+            </a:r>
+          </a:p>
+        </p:txBody>
+      </p:sp>
+      <p:sp>
+        <p:nvSpPr>
+          <p:cNvPr id="4" name="TextBox 3"/>
+          <p:cNvSpPr txBox="1"/>
+          <p:nvPr/>
+        </p:nvSpPr>
+        <p:spPr>
+          <a:xfrm>
+            <a:off x="731520" y="1554480"/>
+            <a:ext cx="10698480" cy="4846320"/>
+          </a:xfrm>
+          <a:prstGeom prst="rect">
+            <a:avLst/>
+          </a:prstGeom>
+          <a:noFill/>
+        </p:spPr>
+        <p:txBody>
           <a:bodyPr wrap="square">
             <a:spAutoFit/>
           </a:bodyPr>
@@ -4215,93 +5312,93 @@
           <a:p>
             <a:pPr>
               <a:spcAft>
-                <a:spcPts val="600"/>
+                <a:spcPts val="500"/>
               </a:spcAft>
             </a:pPr>
             <a:r>
-              <a:rPr b="1" sz="1500">
+              <a:rPr b="1" sz="1400">
                 <a:solidFill>
                   <a:srgbClr val="334155"/>
                 </a:solidFill>
               </a:rPr>
-              <a:t>Capa privada y gobernada: </a:t>
-            </a:r>
-            <a:r>
-              <a:rPr sz="1300">
+              <a:t>Restringido: </a:t>
+            </a:r>
+            <a:r>
+              <a:rPr sz="1200">
                 <a:solidFill>
                   <a:srgbClr val="64748B"/>
                 </a:solidFill>
               </a:rPr>
-              <a:t>sobre cualquier modelo.</a:t>
+              <a:t>local, nunca sale.</a:t>
             </a:r>
           </a:p>
           <a:p>
             <a:pPr>
               <a:spcAft>
-                <a:spcPts val="600"/>
+                <a:spcPts val="500"/>
               </a:spcAft>
             </a:pPr>
             <a:r>
-              <a:rPr b="1" sz="1500">
+              <a:rPr b="1" sz="1400">
                 <a:solidFill>
                   <a:srgbClr val="334155"/>
                 </a:solidFill>
               </a:rPr>
-              <a:t>Enrutador de Privacidad: </a:t>
-            </a:r>
-            <a:r>
-              <a:rPr sz="1300">
+              <a:t>Confidencial/PII: </a:t>
+            </a:r>
+            <a:r>
+              <a:rPr sz="1200">
                 <a:solidFill>
                   <a:srgbClr val="64748B"/>
                 </a:solidFill>
               </a:rPr>
-              <a:t>clasifica, redacta y decide la ruta por cada dato.</a:t>
+              <a:t>VPC o local.</a:t>
             </a:r>
           </a:p>
           <a:p>
             <a:pPr>
               <a:spcAft>
-                <a:spcPts val="600"/>
+                <a:spcPts val="500"/>
               </a:spcAft>
             </a:pPr>
             <a:r>
-              <a:rPr b="1" sz="1500">
+              <a:rPr b="1" sz="1400">
                 <a:solidFill>
                   <a:srgbClr val="334155"/>
                 </a:solidFill>
               </a:rPr>
-              <a:t>RAG por área: </a:t>
-            </a:r>
-            <a:r>
-              <a:rPr sz="1300">
+              <a:t>Interno/Público: </a:t>
+            </a:r>
+            <a:r>
+              <a:rPr sz="1200">
                 <a:solidFill>
                   <a:srgbClr val="64748B"/>
                 </a:solidFill>
               </a:rPr>
-              <a:t>respuestas con fuentes citadas y permisos.</a:t>
+              <a:t>NaN; premium a demanda.</a:t>
             </a:r>
           </a:p>
           <a:p>
             <a:pPr>
               <a:spcAft>
-                <a:spcPts val="600"/>
+                <a:spcPts val="500"/>
               </a:spcAft>
             </a:pPr>
             <a:r>
-              <a:rPr b="1" sz="1500">
+              <a:rPr b="1" sz="1400">
                 <a:solidFill>
                   <a:srgbClr val="334155"/>
                 </a:solidFill>
               </a:rPr>
-              <a:t>Integraciones: </a:t>
-            </a:r>
-            <a:r>
-              <a:rPr sz="1300">
+              <a:t>Inyección: </a:t>
+            </a:r>
+            <a:r>
+              <a:rPr sz="1200">
                 <a:solidFill>
                   <a:srgbClr val="64748B"/>
                 </a:solidFill>
               </a:rPr>
-              <a:t>Google/Microsoft, CRM/ERP, n8n, BD/CSV.</a:t>
+              <a:t>bloqueado y auditado.</a:t>
             </a:r>
           </a:p>
         </p:txBody>
@@ -4347,12 +5444,12 @@
           <a:lstStyle/>
           <a:p>
             <a:r>
-              <a:rPr sz="2800" b="1">
+              <a:rPr sz="2600" b="1">
                 <a:solidFill>
                   <a:srgbClr val="6D28D9"/>
                 </a:solidFill>
               </a:rPr>
-              <a:t>Arquitectura</a:t>
+              <a:t>Enrutador de Privacidad (Privacy Model Router)</a:t>
             </a:r>
           </a:p>
         </p:txBody>
@@ -4381,116 +5478,70 @@
           <a:p>
             <a:pPr>
               <a:spcAft>
-                <a:spcPts val="600"/>
+                <a:spcPts val="500"/>
               </a:spcAft>
             </a:pPr>
             <a:r>
-              <a:rPr b="1" sz="1500">
+              <a:rPr b="1" sz="1400">
                 <a:solidFill>
                   <a:srgbClr val="334155"/>
                 </a:solidFill>
               </a:rPr>
-              <a:t>Portal: </a:t>
-            </a:r>
-            <a:r>
-              <a:rPr sz="1300">
+              <a:t>Logro: </a:t>
+            </a:r>
+            <a:r>
+              <a:rPr sz="1200">
                 <a:solidFill>
                   <a:srgbClr val="64748B"/>
                 </a:solidFill>
               </a:rPr>
-              <a:t>Next.js 15 + Tailwind en Vercel (PWA).</a:t>
+              <a:t>Permite usar IA potente sin exponer información sensible ni depender del criterio del usuario. Es el control que convierte «IA» en «IA gobernada»: soberanía de datos, cumplimiento (LFPDPPP) y trazabilidad por diseño.</a:t>
             </a:r>
           </a:p>
           <a:p>
             <a:pPr>
               <a:spcAft>
-                <a:spcPts val="600"/>
+                <a:spcPts val="500"/>
               </a:spcAft>
             </a:pPr>
             <a:r>
-              <a:rPr b="1" sz="1500">
+              <a:rPr b="1" sz="1400">
                 <a:solidFill>
                   <a:srgbClr val="334155"/>
                 </a:solidFill>
               </a:rPr>
-              <a:t>API: </a:t>
-            </a:r>
-            <a:r>
-              <a:rPr sz="1300">
+              <a:t>Caso de uso: </a:t>
+            </a:r>
+            <a:r>
+              <a:rPr sz="1200">
                 <a:solidFill>
                   <a:srgbClr val="64748B"/>
                 </a:solidFill>
               </a:rPr>
-              <a:t>FastAPI + SQLModel en Render; Postgres (Supabase).</a:t>
+              <a:t>Un analista pega un contrato con cláusula NDA y datos bancarios. El router lo clasifica como Confidencial con PII, lo mantiene en la ruta privada (VPC/local), redacta los identificadores y deja constancia auditable — sin que el analista decida nada.</a:t>
             </a:r>
           </a:p>
           <a:p>
             <a:pPr>
               <a:spcAft>
-                <a:spcPts val="600"/>
+                <a:spcPts val="500"/>
               </a:spcAft>
             </a:pPr>
             <a:r>
-              <a:rPr b="1" sz="1500">
+              <a:rPr b="1" sz="1400">
                 <a:solidFill>
                   <a:srgbClr val="334155"/>
                 </a:solidFill>
               </a:rPr>
-              <a:t>RAG: </a:t>
-            </a:r>
-            <a:r>
-              <a:rPr sz="1300">
+              <a:t>Cómo: </a:t>
+            </a:r>
+            <a:r>
+              <a:rPr sz="1200">
                 <a:solidFill>
                   <a:srgbClr val="64748B"/>
                 </a:solidFill>
               </a:rPr>
-              <a:t>embeddings cifrados + reranking + citas.</a:t>
-            </a:r>
-          </a:p>
-          <a:p>
-            <a:pPr>
-              <a:spcAft>
-                <a:spcPts val="600"/>
-              </a:spcAft>
-            </a:pPr>
-            <a:r>
-              <a:rPr b="1" sz="1500">
-                <a:solidFill>
-                  <a:srgbClr val="334155"/>
-                </a:solidFill>
-              </a:rPr>
-              <a:t>Modelos: </a:t>
-            </a:r>
-            <a:r>
-              <a:rPr sz="1300">
-                <a:solidFill>
-                  <a:srgbClr val="64748B"/>
-                </a:solidFill>
-              </a:rPr>
-              <a:t>local (Ollama) · VPC (vLLM) · open (NaN) · premium.</a:t>
-            </a:r>
-          </a:p>
-          <a:p>
-            <a:pPr>
-              <a:spcAft>
-                <a:spcPts val="600"/>
-              </a:spcAft>
-            </a:pPr>
-            <a:r>
-              <a:rPr b="1" sz="1500">
-                <a:solidFill>
-                  <a:srgbClr val="334155"/>
-                </a:solidFill>
-              </a:rPr>
-              <a:t>CI/CD: </a:t>
-            </a:r>
-            <a:r>
-              <a:rPr sz="1300">
-                <a:solidFill>
-                  <a:srgbClr val="64748B"/>
-                </a:solidFill>
-              </a:rPr>
-              <a:t>dev → qa → main con pytest + build.</a:t>
+              <a:t>El usuario solo escribe su consulta o sube su documento; no elige modelo. …</a:t>
             </a:r>
           </a:p>
         </p:txBody>
@@ -4536,12 +5587,12 @@
           <a:lstStyle/>
           <a:p>
             <a:r>
-              <a:rPr sz="2800" b="1">
+              <a:rPr sz="2600" b="1">
                 <a:solidFill>
                   <a:srgbClr val="6D28D9"/>
                 </a:solidFill>
               </a:rPr>
-              <a:t>Enrutador de Privacidad</a:t>
+              <a:t>RAG documental por área</a:t>
             </a:r>
           </a:p>
         </p:txBody>
@@ -4554,8 +5605,8 @@
         </p:nvSpPr>
         <p:spPr>
           <a:xfrm>
-            <a:off x="640080" y="1325880"/>
-            <a:ext cx="10972800" cy="914400"/>
+            <a:off x="731520" y="1554480"/>
+            <a:ext cx="10698480" cy="4846320"/>
           </a:xfrm>
           <a:prstGeom prst="rect">
             <a:avLst/>
@@ -4563,39 +5614,6 @@
           <a:noFill/>
         </p:spPr>
         <p:txBody>
-          <a:bodyPr wrap="none">
-            <a:spAutoFit/>
-          </a:bodyPr>
-          <a:lstStyle/>
-          <a:p>
-            <a:r>
-              <a:rPr sz="1600">
-                <a:solidFill>
-                  <a:srgbClr val="64748B"/>
-                </a:solidFill>
-              </a:rPr>
-              <a:t>El usuario nunca elige el modelo: lo decide la política.</a:t>
-            </a:r>
-          </a:p>
-        </p:txBody>
-      </p:sp>
-      <p:sp>
-        <p:nvSpPr>
-          <p:cNvPr id="4" name="TextBox 3"/>
-          <p:cNvSpPr txBox="1"/>
-          <p:nvPr/>
-        </p:nvSpPr>
-        <p:spPr>
-          <a:xfrm>
-            <a:off x="731520" y="1554480"/>
-            <a:ext cx="10698480" cy="4846320"/>
-          </a:xfrm>
-          <a:prstGeom prst="rect">
-            <a:avLst/>
-          </a:prstGeom>
-          <a:noFill/>
-        </p:spPr>
-        <p:txBody>
           <a:bodyPr wrap="square">
             <a:spAutoFit/>
           </a:bodyPr>
@@ -4603,93 +5621,70 @@
           <a:p>
             <a:pPr>
               <a:spcAft>
-                <a:spcPts val="600"/>
+                <a:spcPts val="500"/>
               </a:spcAft>
             </a:pPr>
             <a:r>
-              <a:rPr b="1" sz="1500">
+              <a:rPr b="1" sz="1400">
                 <a:solidFill>
                   <a:srgbClr val="334155"/>
                 </a:solidFill>
               </a:rPr>
-              <a:t>Restringido: </a:t>
-            </a:r>
-            <a:r>
-              <a:rPr sz="1300">
+              <a:t>Logro: </a:t>
+            </a:r>
+            <a:r>
+              <a:rPr sz="1200">
                 <a:solidFill>
                   <a:srgbClr val="64748B"/>
                 </a:solidFill>
               </a:rPr>
-              <a:t>Local, nunca sale.</a:t>
+              <a:t>Convierte el conocimiento disperso (propuestas, licitaciones, ISO, manuales) en respuestas confiables con cita y respetando permisos. Reduce el «inventar» del modelo y el riesgo de fuga entre áreas.</a:t>
             </a:r>
           </a:p>
           <a:p>
             <a:pPr>
               <a:spcAft>
-                <a:spcPts val="600"/>
+                <a:spcPts val="500"/>
               </a:spcAft>
             </a:pPr>
             <a:r>
-              <a:rPr b="1" sz="1500">
+              <a:rPr b="1" sz="1400">
                 <a:solidFill>
                   <a:srgbClr val="334155"/>
                 </a:solidFill>
               </a:rPr>
-              <a:t>Confidencial / PII: </a:t>
-            </a:r>
-            <a:r>
-              <a:rPr sz="1300">
+              <a:t>Caso de uso: </a:t>
+            </a:r>
+            <a:r>
+              <a:rPr sz="1200">
                 <a:solidFill>
                   <a:srgbClr val="64748B"/>
                 </a:solidFill>
               </a:rPr>
-              <a:t>VPC o local.</a:t>
+              <a:t>El área de Ventas pregunta «¿qué incluimos en la última propuesta a ACME?» y obtiene la respuesta citando el documento exacto, sin ver documentos de RH o Finanzas.</a:t>
             </a:r>
           </a:p>
           <a:p>
             <a:pPr>
               <a:spcAft>
-                <a:spcPts val="600"/>
+                <a:spcPts val="500"/>
               </a:spcAft>
             </a:pPr>
             <a:r>
-              <a:rPr b="1" sz="1500">
+              <a:rPr b="1" sz="1400">
                 <a:solidFill>
                   <a:srgbClr val="334155"/>
                 </a:solidFill>
               </a:rPr>
-              <a:t>Interno / Público: </a:t>
-            </a:r>
-            <a:r>
-              <a:rPr sz="1300">
+              <a:t>Cómo: </a:t>
+            </a:r>
+            <a:r>
+              <a:rPr sz="1200">
                 <a:solidFill>
                   <a:srgbClr val="64748B"/>
                 </a:solidFill>
               </a:rPr>
-              <a:t>NaN (open); premium a demanda.</a:t>
-            </a:r>
-          </a:p>
-          <a:p>
-            <a:pPr>
-              <a:spcAft>
-                <a:spcPts val="600"/>
-              </a:spcAft>
-            </a:pPr>
-            <a:r>
-              <a:rPr b="1" sz="1500">
-                <a:solidFill>
-                  <a:srgbClr val="334155"/>
-                </a:solidFill>
-              </a:rPr>
-              <a:t>Inyección/exfiltración: </a:t>
-            </a:r>
-            <a:r>
-              <a:rPr sz="1300">
-                <a:solidFill>
-                  <a:srgbClr val="64748B"/>
-                </a:solidFill>
-              </a:rPr>
-              <a:t>Bloqueado y auditado.</a:t>
+              <a:t>Documentos → Subir: asigna área y categoría; revisa el tratamiento detectado. …</a:t>
             </a:r>
           </a:p>
         </p:txBody>
@@ -4735,12 +5730,12 @@
           <a:lstStyle/>
           <a:p>
             <a:r>
-              <a:rPr sz="2800" b="1">
+              <a:rPr sz="2600" b="1">
                 <a:solidFill>
                   <a:srgbClr val="6D28D9"/>
                 </a:solidFill>
               </a:rPr>
-              <a:t>NaN-primero + cascada</a:t>
+              <a:t>Reranking del RAG (precisión)</a:t>
             </a:r>
           </a:p>
         </p:txBody>
@@ -4769,93 +5764,70 @@
           <a:p>
             <a:pPr>
               <a:spcAft>
-                <a:spcPts val="600"/>
+                <a:spcPts val="500"/>
               </a:spcAft>
             </a:pPr>
             <a:r>
-              <a:rPr b="1" sz="1500">
+              <a:rPr b="1" sz="1400">
                 <a:solidFill>
                   <a:srgbClr val="334155"/>
                 </a:solidFill>
               </a:rPr>
-              <a:t>Inicio: </a:t>
-            </a:r>
-            <a:r>
-              <a:rPr sz="1300">
+              <a:t>Logro: </a:t>
+            </a:r>
+            <a:r>
+              <a:rPr sz="1200">
                 <a:solidFill>
                   <a:srgbClr val="64748B"/>
                 </a:solidFill>
               </a:rPr>
-              <a:t>datos no sensibles empiezan en NaN (barato/rápido).</a:t>
+              <a:t>Sube notablemente la precisión de las respuestas con fuentes: el modelo recibe primero los fragmentos verdaderamente relevantes, no solo los «parecidos» por vector.</a:t>
             </a:r>
           </a:p>
           <a:p>
             <a:pPr>
               <a:spcAft>
-                <a:spcPts val="600"/>
+                <a:spcPts val="500"/>
               </a:spcAft>
             </a:pPr>
             <a:r>
-              <a:rPr b="1" sz="1500">
+              <a:rPr b="1" sz="1400">
                 <a:solidFill>
                   <a:srgbClr val="334155"/>
                 </a:solidFill>
               </a:rPr>
-              <a:t>Escalada: </a:t>
-            </a:r>
-            <a:r>
-              <a:rPr sz="1300">
+              <a:t>Caso de uso: </a:t>
+            </a:r>
+            <a:r>
+              <a:rPr sz="1200">
                 <a:solidFill>
                   <a:srgbClr val="64748B"/>
                 </a:solidFill>
               </a:rPr>
-              <a:t>premium solo con «máxima precisión» o si la respuesta es insuficiente.</a:t>
+              <a:t>En una base de 10.000 fragmentos, la pregunta recupera 20 candidatos y el reranker deja los 4 más pertinentes arriba, mejorando la calidad de la cita y la respuesta.</a:t>
             </a:r>
           </a:p>
           <a:p>
             <a:pPr>
               <a:spcAft>
-                <a:spcPts val="600"/>
+                <a:spcPts val="500"/>
               </a:spcAft>
             </a:pPr>
             <a:r>
-              <a:rPr b="1" sz="1500">
+              <a:rPr b="1" sz="1400">
                 <a:solidFill>
                   <a:srgbClr val="334155"/>
                 </a:solidFill>
               </a:rPr>
-              <a:t>Sin premium: </a:t>
-            </a:r>
-            <a:r>
-              <a:rPr sz="1300">
+              <a:t>Cómo: </a:t>
+            </a:r>
+            <a:r>
+              <a:rPr sz="1200">
                 <a:solidFill>
                   <a:srgbClr val="64748B"/>
                 </a:solidFill>
               </a:rPr>
-              <a:t>todo en NaN; sin NaN, modo demostración.</a:t>
-            </a:r>
-          </a:p>
-          <a:p>
-            <a:pPr>
-              <a:spcAft>
-                <a:spcPts val="600"/>
-              </a:spcAft>
-            </a:pPr>
-            <a:r>
-              <a:rPr b="1" sz="1500">
-                <a:solidFill>
-                  <a:srgbClr val="334155"/>
-                </a:solidFill>
-              </a:rPr>
-              <a:t>Eficiencia: </a:t>
-            </a:r>
-            <a:r>
-              <a:rPr sz="1300">
-                <a:solidFill>
-                  <a:srgbClr val="64748B"/>
-                </a:solidFill>
-              </a:rPr>
-              <a:t>condensación + tope de gasto + rerank.</a:t>
+              <a:t>Admin → Eficiencia de tokens → activa «Reranking RAG». …</a:t>
             </a:r>
           </a:p>
         </p:txBody>
@@ -4901,12 +5873,12 @@
           <a:lstStyle/>
           <a:p>
             <a:r>
-              <a:rPr sz="2800" b="1">
+              <a:rPr sz="2600" b="1">
                 <a:solidFill>
                   <a:srgbClr val="6D28D9"/>
                 </a:solidFill>
               </a:rPr>
-              <a:t>Módulos funcionales (1/2)</a:t>
+              <a:t>Cascada NaN → premium y eficiencia de tokens</a:t>
             </a:r>
           </a:p>
         </p:txBody>
@@ -4935,139 +5907,70 @@
           <a:p>
             <a:pPr>
               <a:spcAft>
-                <a:spcPts val="600"/>
+                <a:spcPts val="500"/>
               </a:spcAft>
             </a:pPr>
             <a:r>
-              <a:rPr b="1" sz="1500">
+              <a:rPr b="1" sz="1400">
                 <a:solidFill>
                   <a:srgbClr val="334155"/>
                 </a:solidFill>
               </a:rPr>
-              <a:t>Casos de uso (recetas): </a:t>
-            </a:r>
-            <a:r>
-              <a:rPr sz="1300">
+              <a:t>Logro: </a:t>
+            </a:r>
+            <a:r>
+              <a:rPr sz="1200">
                 <a:solidFill>
                   <a:srgbClr val="64748B"/>
                 </a:solidFill>
               </a:rPr>
-              <a:t>Genera entregables (propuestas, cartas, reportes, licitaciones) con un paso universal objetivo/notas/formato y grounding por categoría. Borrador → aprobar → exportar a Word/PDF/Markdown/PPTX/XLSX. Reporte por industria con plantillas por sector.</a:t>
+              <a:t>Calidad cuando importa, costo bajo por defecto. Evita pagar premium en todo y reduce los tokens enviados (condensación), con ahorro acumulado visible.</a:t>
             </a:r>
           </a:p>
           <a:p>
             <a:pPr>
               <a:spcAft>
-                <a:spcPts val="600"/>
+                <a:spcPts val="500"/>
               </a:spcAft>
             </a:pPr>
             <a:r>
-              <a:rPr b="1" sz="1500">
+              <a:rPr b="1" sz="1400">
                 <a:solidFill>
                   <a:srgbClr val="334155"/>
                 </a:solidFill>
               </a:rPr>
-              <a:t>Agentes verticales: </a:t>
-            </a:r>
-            <a:r>
-              <a:rPr sz="1300">
+              <a:t>Caso de uso: </a:t>
+            </a:r>
+            <a:r>
+              <a:rPr sz="1200">
                 <a:solidFill>
                   <a:srgbClr val="64748B"/>
                 </a:solidFill>
               </a:rPr>
-              <a:t>Agentes especializados (Document Intelligence, Cyber Diagnostic, Proposal/SOW, Executive Copilot) configurables por área; cada respuesta pasa por el router de privacidad y cita fuentes.</a:t>
+              <a:t>Un PDF de 40 páginas se condensa con NaN a un extracto; si el usuario pide «máxima precisión», premium recibe solo ese extracto y refina — pagando una fracción.</a:t>
             </a:r>
           </a:p>
           <a:p>
             <a:pPr>
               <a:spcAft>
-                <a:spcPts val="600"/>
+                <a:spcPts val="500"/>
               </a:spcAft>
             </a:pPr>
             <a:r>
-              <a:rPr b="1" sz="1500">
+              <a:rPr b="1" sz="1400">
                 <a:solidFill>
                   <a:srgbClr val="334155"/>
                 </a:solidFill>
               </a:rPr>
-              <a:t>Chat con fuentes: </a:t>
-            </a:r>
-            <a:r>
-              <a:rPr sz="1300">
+              <a:t>Cómo: </a:t>
+            </a:r>
+            <a:r>
+              <a:rPr sz="1200">
                 <a:solidFill>
                   <a:srgbClr val="64748B"/>
                 </a:solidFill>
               </a:rPr>
-              <a:t>3 modos de contexto (sin contexto / todo el RAG / elegir documentos), toggles de máxima precisión (cascada) y memoria; banner con clasificación y ruta real; exportable.</a:t>
-            </a:r>
-          </a:p>
-          <a:p>
-            <a:pPr>
-              <a:spcAft>
-                <a:spcPts val="600"/>
-              </a:spcAft>
-            </a:pPr>
-            <a:r>
-              <a:rPr b="1" sz="1500">
-                <a:solidFill>
-                  <a:srgbClr val="334155"/>
-                </a:solidFill>
-              </a:rPr>
-              <a:t>Notebooks: </a:t>
-            </a:r>
-            <a:r>
-              <a:rPr sz="1300">
-                <a:solidFill>
-                  <a:srgbClr val="64748B"/>
-                </a:solidFill>
-              </a:rPr>
-              <a:t>Estilo NotebookLM privado: fuentes + preguntas citadas + artefactos (resumen, FAQ, guía, briefing, cronología) acotados a esos documentos.</a:t>
-            </a:r>
-          </a:p>
-          <a:p>
-            <a:pPr>
-              <a:spcAft>
-                <a:spcPts val="600"/>
-              </a:spcAft>
-            </a:pPr>
-            <a:r>
-              <a:rPr b="1" sz="1500">
-                <a:solidFill>
-                  <a:srgbClr val="334155"/>
-                </a:solidFill>
-              </a:rPr>
-              <a:t>Documentos y RAG: </a:t>
-            </a:r>
-            <a:r>
-              <a:rPr sz="1300">
-                <a:solidFill>
-                  <a:srgbClr val="64748B"/>
-                </a:solidFill>
-              </a:rPr>
-              <a:t>Repositorio por área + catálogo de categorías; tratamiento auto-detectado (público/interno/confidencial/restringido) y editable; borrar y re-etiquetar; Drive como contexto; índice cifrado.</a:t>
-            </a:r>
-          </a:p>
-          <a:p>
-            <a:pPr>
-              <a:spcAft>
-                <a:spcPts val="600"/>
-              </a:spcAft>
-            </a:pPr>
-            <a:r>
-              <a:rPr b="1" sz="1500">
-                <a:solidFill>
-                  <a:srgbClr val="334155"/>
-                </a:solidFill>
-              </a:rPr>
-              <a:t>Memoria y etiquetas: </a:t>
-            </a:r>
-            <a:r>
-              <a:rPr sz="1300">
-                <a:solidFill>
-                  <a:srgbClr val="64748B"/>
-                </a:solidFill>
-              </a:rPr>
-              <a:t>Memoria persistente de trabajos con búsqueda semántica + por tags; recall en el chat ('¿recuerdas el trabajo C?'); auto-captura al completar casos.</a:t>
+              <a:t>No requiere acción del usuario para el flujo base (todo empieza en NaN). …</a:t>
             </a:r>
           </a:p>
         </p:txBody>
@@ -5113,12 +6016,12 @@
           <a:lstStyle/>
           <a:p>
             <a:r>
-              <a:rPr sz="2800" b="1">
+              <a:rPr sz="2600" b="1">
                 <a:solidFill>
                   <a:srgbClr val="6D28D9"/>
                 </a:solidFill>
               </a:rPr>
-              <a:t>Módulos funcionales (2/2)</a:t>
+              <a:t>Casos de uso (generación de entregables)</a:t>
             </a:r>
           </a:p>
         </p:txBody>
@@ -5147,139 +6050,70 @@
           <a:p>
             <a:pPr>
               <a:spcAft>
-                <a:spcPts val="600"/>
+                <a:spcPts val="500"/>
               </a:spcAft>
             </a:pPr>
             <a:r>
-              <a:rPr b="1" sz="1500">
+              <a:rPr b="1" sz="1400">
                 <a:solidFill>
                   <a:srgbClr val="334155"/>
                 </a:solidFill>
               </a:rPr>
-              <a:t>Generar imágenes: </a:t>
-            </a:r>
-            <a:r>
-              <a:rPr sz="1300">
+              <a:t>Logro: </a:t>
+            </a:r>
+            <a:r>
+              <a:rPr sz="1200">
                 <a:solidFill>
                   <a:srgbClr val="64748B"/>
                 </a:solidFill>
               </a:rPr>
-              <a:t>Texto→imagen (ruta estándar OpenAI), relación de aspecto y variantes; galería por área; PII redactada; auditada.</a:t>
+              <a:t>Pasa de horas a minutos en entregables repetitivos, con marca de la empresa, estructura consistente y datos citados. «Elige qué lograr, da lo mínimo; tú solo apruebas.»</a:t>
             </a:r>
           </a:p>
           <a:p>
             <a:pPr>
               <a:spcAft>
-                <a:spcPts val="600"/>
+                <a:spcPts val="500"/>
               </a:spcAft>
             </a:pPr>
             <a:r>
-              <a:rPr b="1" sz="1500">
+              <a:rPr b="1" sz="1400">
                 <a:solidFill>
                   <a:srgbClr val="334155"/>
                 </a:solidFill>
               </a:rPr>
-              <a:t>Flujogramas: </a:t>
-            </a:r>
-            <a:r>
-              <a:rPr sz="1300">
+              <a:t>Caso de uso: </a:t>
+            </a:r>
+            <a:r>
+              <a:rPr sz="1200">
                 <a:solidFill>
                   <a:srgbClr val="64748B"/>
                 </a:solidFill>
               </a:rPr>
-              <a:t>La lógica del producto navegable: los flujos base del blueprint + flujo de caso + diseño libre.</a:t>
+              <a:t>Un ejecutivo elige «Propuesta comercial», pone cliente/servicio/monto, revisa el borrador y descarga un .docx con portada, secciones y pie confidencial.</a:t>
             </a:r>
           </a:p>
           <a:p>
             <a:pPr>
               <a:spcAft>
-                <a:spcPts val="600"/>
+                <a:spcPts val="500"/>
               </a:spcAft>
             </a:pPr>
             <a:r>
-              <a:rPr b="1" sz="1500">
+              <a:rPr b="1" sz="1400">
                 <a:solidFill>
                   <a:srgbClr val="334155"/>
                 </a:solidFill>
               </a:rPr>
-              <a:t>Tableros: </a:t>
-            </a:r>
-            <a:r>
-              <a:rPr sz="1300">
+              <a:t>Cómo: </a:t>
+            </a:r>
+            <a:r>
+              <a:rPr sz="1200">
                 <a:solidFill>
                   <a:srgbClr val="64748B"/>
                 </a:solidFill>
               </a:rPr>
-              <a:t>Dashboards a la medida: describe qué medir, agrega KPIs y gráficas en vivo (tokens por fuente, casos por receta, costo por ruta) + KPIs manuales.</a:t>
-            </a:r>
-          </a:p>
-          <a:p>
-            <a:pPr>
-              <a:spcAft>
-                <a:spcPts val="600"/>
-              </a:spcAft>
-            </a:pPr>
-            <a:r>
-              <a:rPr b="1" sz="1500">
-                <a:solidFill>
-                  <a:srgbClr val="334155"/>
-                </a:solidFill>
-              </a:rPr>
-              <a:t>Trámites y casos (MCP): </a:t>
-            </a:r>
-            <a:r>
-              <a:rPr sz="1300">
-                <a:solidFill>
-                  <a:srgbClr val="64748B"/>
-                </a:solidFill>
-              </a:rPr>
-              <a:t>Catálogo curado por país/estado/empresa por ejes de desarrollo; convierte un trámite en propuesta de caso; aterriza (grounding) las respuestas.</a:t>
-            </a:r>
-          </a:p>
-          <a:p>
-            <a:pPr>
-              <a:spcAft>
-                <a:spcPts val="600"/>
-              </a:spcAft>
-            </a:pPr>
-            <a:r>
-              <a:rPr b="1" sz="1500">
-                <a:solidFill>
-                  <a:srgbClr val="334155"/>
-                </a:solidFill>
-              </a:rPr>
-              <a:t>App Studio: </a:t>
-            </a:r>
-            <a:r>
-              <a:rPr sz="1300">
-                <a:solidFill>
-                  <a:srgbClr val="64748B"/>
-                </a:solidFill>
-              </a:rPr>
-              <a:t>Construye mini-apps con IA y publícalas (pago por despliegue).</a:t>
-            </a:r>
-          </a:p>
-          <a:p>
-            <a:pPr>
-              <a:spcAft>
-                <a:spcPts val="600"/>
-              </a:spcAft>
-            </a:pPr>
-            <a:r>
-              <a:rPr b="1" sz="1500">
-                <a:solidFill>
-                  <a:srgbClr val="334155"/>
-                </a:solidFill>
-              </a:rPr>
-              <a:t>Automatizaciones: </a:t>
-            </a:r>
-            <a:r>
-              <a:rPr sz="1300">
-                <a:solidFill>
-                  <a:srgbClr val="64748B"/>
-                </a:solidFill>
-              </a:rPr>
-              <a:t>Disparador (manual/programado/evento) → acción (workflow n8n / caso / conector / notificar), con plantillas y ejecución manual.</a:t>
+              <a:t>Casos de uso → elige la receta. …</a:t>
             </a:r>
           </a:p>
         </p:txBody>
@@ -5325,12 +6159,12 @@
           <a:lstStyle/>
           <a:p>
             <a:r>
-              <a:rPr sz="2800" b="1">
+              <a:rPr sz="2600" b="1">
                 <a:solidFill>
                   <a:srgbClr val="6D28D9"/>
                 </a:solidFill>
               </a:rPr>
-              <a:t>Integraciones</a:t>
+              <a:t>Agentes verticales</a:t>
             </a:r>
           </a:p>
         </p:txBody>
@@ -5359,93 +6193,70 @@
           <a:p>
             <a:pPr>
               <a:spcAft>
-                <a:spcPts val="600"/>
+                <a:spcPts val="500"/>
               </a:spcAft>
             </a:pPr>
             <a:r>
-              <a:rPr b="1" sz="1500">
+              <a:rPr b="1" sz="1400">
                 <a:solidFill>
                   <a:srgbClr val="334155"/>
                 </a:solidFill>
               </a:rPr>
-              <a:t>Correo: </a:t>
-            </a:r>
-            <a:r>
-              <a:rPr sz="1300">
+              <a:t>Logro: </a:t>
+            </a:r>
+            <a:r>
+              <a:rPr sz="1200">
                 <a:solidFill>
                   <a:srgbClr val="64748B"/>
                 </a:solidFill>
               </a:rPr>
-              <a:t>Outlook/Gmail/IMAP, multi-cuenta.</a:t>
+              <a:t>Experiencia experta lista para usar por área, sin construir prompts desde cero, con la misma gobernanza de privacidad.</a:t>
             </a:r>
           </a:p>
           <a:p>
             <a:pPr>
               <a:spcAft>
-                <a:spcPts val="600"/>
+                <a:spcPts val="500"/>
               </a:spcAft>
             </a:pPr>
             <a:r>
-              <a:rPr b="1" sz="1500">
+              <a:rPr b="1" sz="1400">
                 <a:solidFill>
                   <a:srgbClr val="334155"/>
                 </a:solidFill>
               </a:rPr>
-              <a:t>Acciones: </a:t>
-            </a:r>
-            <a:r>
-              <a:rPr sz="1300">
+              <a:t>Caso de uso: </a:t>
+            </a:r>
+            <a:r>
+              <a:rPr sz="1200">
                 <a:solidFill>
                   <a:srgbClr val="64748B"/>
                 </a:solidFill>
               </a:rPr>
-              <a:t>Gmail/Outlook, Calendar, Sheets/Excel, Teams, SharePoint.</a:t>
+              <a:t>El equipo de seguridad usa Cyber Diagnostic para un diagnóstico y roadmap citando las políticas internas.</a:t>
             </a:r>
           </a:p>
           <a:p>
             <a:pPr>
               <a:spcAft>
-                <a:spcPts val="600"/>
+                <a:spcPts val="500"/>
               </a:spcAft>
             </a:pPr>
             <a:r>
-              <a:rPr b="1" sz="1500">
+              <a:rPr b="1" sz="1400">
                 <a:solidFill>
                   <a:srgbClr val="334155"/>
                 </a:solidFill>
               </a:rPr>
-              <a:t>Conectores/Webhooks: </a:t>
-            </a:r>
-            <a:r>
-              <a:rPr sz="1300">
+              <a:t>Cómo: </a:t>
+            </a:r>
+            <a:r>
+              <a:rPr sz="1200">
                 <a:solidFill>
                   <a:srgbClr val="64748B"/>
                 </a:solidFill>
               </a:rPr>
-              <a:t>CRM/ERP + HMAC entrante.</a:t>
-            </a:r>
-          </a:p>
-          <a:p>
-            <a:pPr>
-              <a:spcAft>
-                <a:spcPts val="600"/>
-              </a:spcAft>
-            </a:pPr>
-            <a:r>
-              <a:rPr b="1" sz="1500">
-                <a:solidFill>
-                  <a:srgbClr val="334155"/>
-                </a:solidFill>
-              </a:rPr>
-              <a:t>Legados: </a:t>
-            </a:r>
-            <a:r>
-              <a:rPr sz="1300">
-                <a:solidFill>
-                  <a:srgbClr val="64748B"/>
-                </a:solidFill>
-              </a:rPr>
-              <a:t>BD solo lectura y CSV → RAG; n8n para el resto.</a:t>
+              <a:t>Agentes → elige el agente y conversa. …</a:t>
             </a:r>
           </a:p>
         </p:txBody>

</xml_diff>